<commit_message>
Organiza configuracoes e melhora o visual da apresentacao
</commit_message>
<xml_diff>
--- a/apresentacao_agentes.pptx
+++ b/apresentacao_agentes.pptx
@@ -2,18 +2,18 @@
 <file path=ppt/presentation.xml><?xml version="1.0" encoding="utf-8"?>
 <p:presentation xmlns:p="http://schemas.openxmlformats.org/presentationml/2006/main">
   <p:sldMasterIdLst>
-    <p:sldMasterId xmlns:r="http://schemas.openxmlformats.org/officeDocument/2006/relationships" id="2147483648" r:id="Ra70e5b23ae9b4c9f"/>
+    <p:sldMasterId xmlns:r="http://schemas.openxmlformats.org/officeDocument/2006/relationships" id="2147483648" r:id="R527a09dabb0c4e45"/>
   </p:sldMasterIdLst>
   <p:notesMasterIdLst>
-    <p:notesMasterId xmlns:r="http://schemas.openxmlformats.org/officeDocument/2006/relationships" r:id="R18d42d37de3545f9"/>
+    <p:notesMasterId xmlns:r="http://schemas.openxmlformats.org/officeDocument/2006/relationships" r:id="R35ef1386e48d453d"/>
   </p:notesMasterIdLst>
   <p:sldIdLst>
-    <p:sldId xmlns:r="http://schemas.openxmlformats.org/officeDocument/2006/relationships" id="256" r:id="R0d42891dae0b4c1f"/>
-    <p:sldId xmlns:r="http://schemas.openxmlformats.org/officeDocument/2006/relationships" id="257" r:id="R4d47985ac1af4403"/>
-    <p:sldId xmlns:r="http://schemas.openxmlformats.org/officeDocument/2006/relationships" id="258" r:id="Rc7f8738873994ac1"/>
-    <p:sldId xmlns:r="http://schemas.openxmlformats.org/officeDocument/2006/relationships" id="259" r:id="Rbbe8368241494daf"/>
-    <p:sldId xmlns:r="http://schemas.openxmlformats.org/officeDocument/2006/relationships" id="260" r:id="Rc8a1fa1836e14358"/>
-    <p:sldId xmlns:r="http://schemas.openxmlformats.org/officeDocument/2006/relationships" id="261" r:id="R9e6183b9f0b2404e"/>
+    <p:sldId xmlns:r="http://schemas.openxmlformats.org/officeDocument/2006/relationships" id="256" r:id="R835389b5c3d9454c"/>
+    <p:sldId xmlns:r="http://schemas.openxmlformats.org/officeDocument/2006/relationships" id="257" r:id="R22e9d9c80f1441a0"/>
+    <p:sldId xmlns:r="http://schemas.openxmlformats.org/officeDocument/2006/relationships" id="258" r:id="R112c046797b04fa7"/>
+    <p:sldId xmlns:r="http://schemas.openxmlformats.org/officeDocument/2006/relationships" id="259" r:id="R2a00ccaaef924759"/>
+    <p:sldId xmlns:r="http://schemas.openxmlformats.org/officeDocument/2006/relationships" id="260" r:id="R3fb428268f9b4a58"/>
+    <p:sldId xmlns:r="http://schemas.openxmlformats.org/officeDocument/2006/relationships" id="261" r:id="Ra97fe488d5584cab"/>
   </p:sldIdLst>
   <p:sldSz cx="12192000" cy="6858000"/>
   <p:notesSz cx="6858000" cy="9144000"/>
@@ -985,7 +985,7 @@
   </p:cSld>
   <p:clrMap bg1="lt1" tx1="dk1" bg2="lt2" tx2="dk2" accent1="accent1" accent2="accent2" accent3="accent3" accent4="accent4" accent5="accent5" accent6="accent6" hlink="hlink" folHlink="folHlink"/>
   <p:sldLayoutIdLst>
-    <p:sldLayoutId xmlns:r="http://schemas.openxmlformats.org/officeDocument/2006/relationships" id="2147483649" r:id="R01d34adc82324cc6"/>
+    <p:sldLayoutId xmlns:r="http://schemas.openxmlformats.org/officeDocument/2006/relationships" id="2147483649" r:id="Rc871dba73d3b465c"/>
   </p:sldLayoutIdLst>
   <p:txStyles>
     <p:titleStyle>
@@ -2111,8 +2111,8 @@
         </p:nvSpPr>
         <p:spPr>
           <a:xfrm xmlns:a="http://schemas.openxmlformats.org/drawingml/2006/main">
-            <a:off x="609600" y="400050"/>
-            <a:ext cx="10972800" cy="952500"/>
+            <a:off x="609600" y="352425"/>
+            <a:ext cx="10972800" cy="1219200"/>
           </a:xfrm>
           <a:prstGeom xmlns:a="http://schemas.openxmlformats.org/drawingml/2006/main" prst="rect">
             <a:avLst/>
@@ -2129,7 +2129,8 @@
           <a:lstStyle xmlns:a="http://schemas.openxmlformats.org/drawingml/2006/main"/>
           <a:p xmlns:a="http://schemas.openxmlformats.org/drawingml/2006/main">
             <a:pPr>
-              <a:defRPr sz="3300" b="1">
+              <a:buNone/>
+              <a:defRPr sz="3675" b="1">
                 <a:solidFill>
                   <a:srgbClr val="202428"/>
                 </a:solidFill>
@@ -2139,7 +2140,7 @@
               </a:defRPr>
             </a:pPr>
             <a:r>
-              <a:rPr sz="3300" b="1">
+              <a:rPr sz="3675" b="1">
                 <a:solidFill>
                   <a:srgbClr val="202428"/>
                 </a:solidFill>
@@ -2147,7 +2148,31 @@
                 <a:ea typeface="Arial"/>
                 <a:cs typeface="Arial"/>
               </a:rPr>
-              <a:t>Avaliação experimental de agentes inteligentes</a:t>
+              <a:t>Avaliação experimental</a:t>
+            </a:r>
+          </a:p>
+          <a:p xmlns:a="http://schemas.openxmlformats.org/drawingml/2006/main">
+            <a:pPr>
+              <a:buNone/>
+              <a:defRPr sz="3675" b="1">
+                <a:solidFill>
+                  <a:srgbClr val="202428"/>
+                </a:solidFill>
+                <a:latin typeface="Arial"/>
+                <a:ea typeface="Arial"/>
+                <a:cs typeface="Arial"/>
+              </a:defRPr>
+            </a:pPr>
+            <a:r>
+              <a:rPr sz="3675" b="1">
+                <a:solidFill>
+                  <a:srgbClr val="202428"/>
+                </a:solidFill>
+                <a:latin typeface="Arial"/>
+                <a:ea typeface="Arial"/>
+                <a:cs typeface="Arial"/>
+              </a:rPr>
+              <a:t>de agentes inteligentes</a:t>
             </a:r>
           </a:p>
         </p:txBody>
@@ -2186,6 +2211,7 @@
           <a:lstStyle xmlns:a="http://schemas.openxmlformats.org/drawingml/2006/main"/>
           <a:p xmlns:a="http://schemas.openxmlformats.org/drawingml/2006/main">
             <a:pPr>
+              <a:buNone/>
               <a:defRPr sz="1425" b="0">
                 <a:solidFill>
                   <a:srgbClr val="535C62"/>
@@ -2225,8 +2251,8 @@
         </p:nvSpPr>
         <p:spPr>
           <a:xfrm xmlns:a="http://schemas.openxmlformats.org/drawingml/2006/main">
-            <a:off x="609600" y="1552575"/>
-            <a:ext cx="10972800" cy="523875"/>
+            <a:off x="609600" y="1752600"/>
+            <a:ext cx="10972800" cy="495300"/>
           </a:xfrm>
           <a:prstGeom xmlns:a="http://schemas.openxmlformats.org/drawingml/2006/main" prst="rect">
             <a:avLst/>
@@ -2243,7 +2269,8 @@
           <a:lstStyle xmlns:a="http://schemas.openxmlformats.org/drawingml/2006/main"/>
           <a:p xmlns:a="http://schemas.openxmlformats.org/drawingml/2006/main">
             <a:pPr>
-              <a:defRPr sz="2325" b="0">
+              <a:buNone/>
+              <a:defRPr sz="2175" b="0">
                 <a:solidFill>
                   <a:srgbClr val="137968"/>
                 </a:solidFill>
@@ -2253,7 +2280,7 @@
               </a:defRPr>
             </a:pPr>
             <a:r>
-              <a:rPr sz="2325" b="0">
+              <a:rPr sz="2175" b="0">
                 <a:solidFill>
                   <a:srgbClr val="137968"/>
                 </a:solidFill>
@@ -2282,8 +2309,8 @@
         </p:nvSpPr>
         <p:spPr>
           <a:xfrm xmlns:a="http://schemas.openxmlformats.org/drawingml/2006/main">
-            <a:off x="609600" y="2447925"/>
-            <a:ext cx="10972800" cy="1524000"/>
+            <a:off x="609600" y="2695575"/>
+            <a:ext cx="3143250" cy="762000"/>
           </a:xfrm>
           <a:prstGeom xmlns:a="http://schemas.openxmlformats.org/drawingml/2006/main" prst="rect">
             <a:avLst/>
@@ -2300,9 +2327,10 @@
           <a:lstStyle xmlns:a="http://schemas.openxmlformats.org/drawingml/2006/main"/>
           <a:p xmlns:a="http://schemas.openxmlformats.org/drawingml/2006/main">
             <a:pPr>
-              <a:defRPr sz="2250" b="0">
-                <a:solidFill>
-                  <a:srgbClr val="202428"/>
+              <a:buNone/>
+              <a:defRPr sz="4650" b="1">
+                <a:solidFill>
+                  <a:srgbClr val="426BA5"/>
                 </a:solidFill>
                 <a:latin typeface="Arial"/>
                 <a:ea typeface="Arial"/>
@@ -2310,61 +2338,15 @@
               </a:defRPr>
             </a:pPr>
             <a:r>
-              <a:rPr sz="2250" b="0">
-                <a:solidFill>
-                  <a:srgbClr val="202428"/>
+              <a:rPr sz="4650" b="1">
+                <a:solidFill>
+                  <a:srgbClr val="426BA5"/>
                 </a:solidFill>
                 <a:latin typeface="Arial"/>
                 <a:ea typeface="Arial"/>
                 <a:cs typeface="Arial"/>
               </a:rPr>
-              <a:t>Ambiente 4 × 4, com sujeira e obstáculos</a:t>
-            </a:r>
-          </a:p>
-          <a:p xmlns:a="http://schemas.openxmlformats.org/drawingml/2006/main">
-            <a:pPr>
-              <a:defRPr sz="2250" b="0">
-                <a:solidFill>
-                  <a:srgbClr val="202428"/>
-                </a:solidFill>
-                <a:latin typeface="Arial"/>
-                <a:ea typeface="Arial"/>
-                <a:cs typeface="Arial"/>
-              </a:defRPr>
-            </a:pPr>
-            <a:r>
-              <a:rPr sz="2250" b="0">
-                <a:solidFill>
-                  <a:srgbClr val="202428"/>
-                </a:solidFill>
-                <a:latin typeface="Arial"/>
-                <a:ea typeface="Arial"/>
-                <a:cs typeface="Arial"/>
-              </a:rPr>
-              <a:t>Três configurações iniciais e 80 períodos por execução</a:t>
-            </a:r>
-          </a:p>
-          <a:p xmlns:a="http://schemas.openxmlformats.org/drawingml/2006/main">
-            <a:pPr>
-              <a:defRPr sz="2250" b="0">
-                <a:solidFill>
-                  <a:srgbClr val="202428"/>
-                </a:solidFill>
-                <a:latin typeface="Arial"/>
-                <a:ea typeface="Arial"/>
-                <a:cs typeface="Arial"/>
-              </a:defRPr>
-            </a:pPr>
-            <a:r>
-              <a:rPr sz="2250" b="0">
-                <a:solidFill>
-                  <a:srgbClr val="202428"/>
-                </a:solidFill>
-                <a:latin typeface="Arial"/>
-                <a:ea typeface="Arial"/>
-                <a:cs typeface="Arial"/>
-              </a:rPr>
-              <a:t>Mesmas condições para comparar os dois agentes</a:t>
+              <a:t>4 × 4</a:t>
             </a:r>
           </a:p>
         </p:txBody>
@@ -2385,8 +2367,8 @@
         </p:nvSpPr>
         <p:spPr>
           <a:xfrm xmlns:a="http://schemas.openxmlformats.org/drawingml/2006/main">
-            <a:off x="609600" y="4457700"/>
-            <a:ext cx="4953000" cy="438150"/>
+            <a:off x="609600" y="4552950"/>
+            <a:ext cx="10972800" cy="428625"/>
           </a:xfrm>
           <a:prstGeom xmlns:a="http://schemas.openxmlformats.org/drawingml/2006/main" prst="rect">
             <a:avLst/>
@@ -2403,7 +2385,8 @@
           <a:lstStyle xmlns:a="http://schemas.openxmlformats.org/drawingml/2006/main"/>
           <a:p xmlns:a="http://schemas.openxmlformats.org/drawingml/2006/main">
             <a:pPr>
-              <a:defRPr sz="2325" b="1">
+              <a:buNone/>
+              <a:defRPr sz="2175" b="1">
                 <a:solidFill>
                   <a:srgbClr val="202428"/>
                 </a:solidFill>
@@ -2413,7 +2396,7 @@
               </a:defRPr>
             </a:pPr>
             <a:r>
-              <a:rPr sz="2325" b="1">
+              <a:rPr sz="2175" b="1">
                 <a:solidFill>
                   <a:srgbClr val="202428"/>
                 </a:solidFill>
@@ -2442,8 +2425,8 @@
         </p:nvSpPr>
         <p:spPr>
           <a:xfrm xmlns:a="http://schemas.openxmlformats.org/drawingml/2006/main">
-            <a:off x="609600" y="5010150"/>
-            <a:ext cx="10972800" cy="857250"/>
+            <a:off x="609600" y="5153025"/>
+            <a:ext cx="10972800" cy="895350"/>
           </a:xfrm>
           <a:prstGeom xmlns:a="http://schemas.openxmlformats.org/drawingml/2006/main" prst="rect">
             <a:avLst/>
@@ -2460,7 +2443,8 @@
           <a:lstStyle xmlns:a="http://schemas.openxmlformats.org/drawingml/2006/main"/>
           <a:p xmlns:a="http://schemas.openxmlformats.org/drawingml/2006/main">
             <a:pPr>
-              <a:defRPr sz="2100" b="0">
+              <a:buNone/>
+              <a:defRPr sz="2025" b="0">
                 <a:solidFill>
                   <a:srgbClr val="202428"/>
                 </a:solidFill>
@@ -2470,7 +2454,7 @@
               </a:defRPr>
             </a:pPr>
             <a:r>
-              <a:rPr sz="2100" b="0">
+              <a:rPr sz="2025" b="0">
                 <a:solidFill>
                   <a:srgbClr val="202428"/>
                 </a:solidFill>
@@ -2478,12 +2462,13 @@
                 <a:ea typeface="Arial"/>
                 <a:cs typeface="Arial"/>
               </a:rPr>
-              <a:t>Sujeira atual e passagens vizinhas.</a:t>
+              <a:t>Sujeira atual e passagens vizinhas. Sem conhecimento prévio do mapa.</a:t>
             </a:r>
           </a:p>
           <a:p xmlns:a="http://schemas.openxmlformats.org/drawingml/2006/main">
             <a:pPr>
-              <a:defRPr sz="2100" b="0">
+              <a:buNone/>
+              <a:defRPr sz="2025" b="0">
                 <a:solidFill>
                   <a:srgbClr val="202428"/>
                 </a:solidFill>
@@ -2493,7 +2478,7 @@
               </a:defRPr>
             </a:pPr>
             <a:r>
-              <a:rPr sz="2100" b="0">
+              <a:rPr sz="2025" b="0">
                 <a:solidFill>
                   <a:srgbClr val="202428"/>
                 </a:solidFill>
@@ -2501,7 +2486,292 @@
                 <a:ea typeface="Arial"/>
                 <a:cs typeface="Arial"/>
               </a:rPr>
-              <a:t>O agente começa sem conhecer o mapa.</a:t>
+              <a:t>Os dois agentes começam nas mesmas condições.</a:t>
+            </a:r>
+          </a:p>
+        </p:txBody>
+      </p:sp>
+      <p:sp>
+        <p:nvSpPr>
+          <p:cNvPr id="8" name="">
+            <a:extLst xmlns:a="http://schemas.openxmlformats.org/drawingml/2006/main">
+              <a:ext uri="{FF2B5EF4-FFF2-40B4-BE49-F238E27FC236}">
+                <a16:creationId xmlns:a16="http://schemas.microsoft.com/office/drawing/2014/main" id="{83555E7C-F4F5-422B-B06E-D1861539D6D0}"/>
+              </a:ext>
+            </a:extLst>
+          </p:cNvPr>
+          <p:cNvSpPr>
+            <a:spLocks xmlns:a="http://schemas.openxmlformats.org/drawingml/2006/main" noGrp="1"/>
+          </p:cNvSpPr>
+          <p:nvPr/>
+        </p:nvSpPr>
+        <p:spPr>
+          <a:xfrm xmlns:a="http://schemas.openxmlformats.org/drawingml/2006/main">
+            <a:off x="609600" y="3495675"/>
+            <a:ext cx="3190875" cy="428625"/>
+          </a:xfrm>
+          <a:prstGeom xmlns:a="http://schemas.openxmlformats.org/drawingml/2006/main" prst="rect">
+            <a:avLst/>
+          </a:prstGeom>
+          <a:noFill xmlns:a="http://schemas.openxmlformats.org/drawingml/2006/main"/>
+          <a:ln xmlns:a="http://schemas.openxmlformats.org/drawingml/2006/main" w="0">
+            <a:noFill/>
+          </a:ln>
+        </p:spPr>
+        <p:txBody>
+          <a:bodyPr xmlns:a="http://schemas.openxmlformats.org/drawingml/2006/main">
+            <a:noAutofit/>
+          </a:bodyPr>
+          <a:lstStyle xmlns:a="http://schemas.openxmlformats.org/drawingml/2006/main"/>
+          <a:p xmlns:a="http://schemas.openxmlformats.org/drawingml/2006/main">
+            <a:pPr>
+              <a:defRPr sz="1875" b="0">
+                <a:solidFill>
+                  <a:srgbClr val="535C62"/>
+                </a:solidFill>
+                <a:latin typeface="Arial"/>
+                <a:ea typeface="Arial"/>
+                <a:cs typeface="Arial"/>
+              </a:defRPr>
+            </a:pPr>
+            <a:r>
+              <a:rPr sz="1875" b="0">
+                <a:solidFill>
+                  <a:srgbClr val="535C62"/>
+                </a:solidFill>
+                <a:latin typeface="Arial"/>
+                <a:ea typeface="Arial"/>
+                <a:cs typeface="Arial"/>
+              </a:rPr>
+              <a:t>dimensões do ambiente</a:t>
+            </a:r>
+          </a:p>
+        </p:txBody>
+      </p:sp>
+      <p:sp>
+        <p:nvSpPr>
+          <p:cNvPr id="9" name="">
+            <a:extLst xmlns:a="http://schemas.openxmlformats.org/drawingml/2006/main">
+              <a:ext uri="{FF2B5EF4-FFF2-40B4-BE49-F238E27FC236}">
+                <a16:creationId xmlns:a16="http://schemas.microsoft.com/office/drawing/2014/main" id="{8AA132C3-704D-48F2-8049-02806A6FA022}"/>
+              </a:ext>
+            </a:extLst>
+          </p:cNvPr>
+          <p:cNvSpPr>
+            <a:spLocks xmlns:a="http://schemas.openxmlformats.org/drawingml/2006/main" noGrp="1"/>
+          </p:cNvSpPr>
+          <p:nvPr/>
+        </p:nvSpPr>
+        <p:spPr>
+          <a:xfrm xmlns:a="http://schemas.openxmlformats.org/drawingml/2006/main">
+            <a:off x="4448175" y="2695575"/>
+            <a:ext cx="3143250" cy="762000"/>
+          </a:xfrm>
+          <a:prstGeom xmlns:a="http://schemas.openxmlformats.org/drawingml/2006/main" prst="rect">
+            <a:avLst/>
+          </a:prstGeom>
+          <a:noFill xmlns:a="http://schemas.openxmlformats.org/drawingml/2006/main"/>
+          <a:ln xmlns:a="http://schemas.openxmlformats.org/drawingml/2006/main" w="0">
+            <a:noFill/>
+          </a:ln>
+        </p:spPr>
+        <p:txBody>
+          <a:bodyPr xmlns:a="http://schemas.openxmlformats.org/drawingml/2006/main">
+            <a:noAutofit/>
+          </a:bodyPr>
+          <a:lstStyle xmlns:a="http://schemas.openxmlformats.org/drawingml/2006/main"/>
+          <a:p xmlns:a="http://schemas.openxmlformats.org/drawingml/2006/main">
+            <a:pPr>
+              <a:defRPr sz="4650" b="1">
+                <a:solidFill>
+                  <a:srgbClr val="137968"/>
+                </a:solidFill>
+                <a:latin typeface="Arial"/>
+                <a:ea typeface="Arial"/>
+                <a:cs typeface="Arial"/>
+              </a:defRPr>
+            </a:pPr>
+            <a:r>
+              <a:rPr sz="4650" b="1">
+                <a:solidFill>
+                  <a:srgbClr val="137968"/>
+                </a:solidFill>
+                <a:latin typeface="Arial"/>
+                <a:ea typeface="Arial"/>
+                <a:cs typeface="Arial"/>
+              </a:rPr>
+              <a:t>3</a:t>
+            </a:r>
+          </a:p>
+        </p:txBody>
+      </p:sp>
+      <p:sp>
+        <p:nvSpPr>
+          <p:cNvPr id="10" name="">
+            <a:extLst xmlns:a="http://schemas.openxmlformats.org/drawingml/2006/main">
+              <a:ext uri="{FF2B5EF4-FFF2-40B4-BE49-F238E27FC236}">
+                <a16:creationId xmlns:a16="http://schemas.microsoft.com/office/drawing/2014/main" id="{09215528-4878-440B-B631-4BF98E96CDF1}"/>
+              </a:ext>
+            </a:extLst>
+          </p:cNvPr>
+          <p:cNvSpPr>
+            <a:spLocks xmlns:a="http://schemas.openxmlformats.org/drawingml/2006/main" noGrp="1"/>
+          </p:cNvSpPr>
+          <p:nvPr/>
+        </p:nvSpPr>
+        <p:spPr>
+          <a:xfrm xmlns:a="http://schemas.openxmlformats.org/drawingml/2006/main">
+            <a:off x="4448175" y="3495675"/>
+            <a:ext cx="3190875" cy="428625"/>
+          </a:xfrm>
+          <a:prstGeom xmlns:a="http://schemas.openxmlformats.org/drawingml/2006/main" prst="rect">
+            <a:avLst/>
+          </a:prstGeom>
+          <a:noFill xmlns:a="http://schemas.openxmlformats.org/drawingml/2006/main"/>
+          <a:ln xmlns:a="http://schemas.openxmlformats.org/drawingml/2006/main" w="0">
+            <a:noFill/>
+          </a:ln>
+        </p:spPr>
+        <p:txBody>
+          <a:bodyPr xmlns:a="http://schemas.openxmlformats.org/drawingml/2006/main">
+            <a:noAutofit/>
+          </a:bodyPr>
+          <a:lstStyle xmlns:a="http://schemas.openxmlformats.org/drawingml/2006/main"/>
+          <a:p xmlns:a="http://schemas.openxmlformats.org/drawingml/2006/main">
+            <a:pPr>
+              <a:defRPr sz="1875" b="0">
+                <a:solidFill>
+                  <a:srgbClr val="535C62"/>
+                </a:solidFill>
+                <a:latin typeface="Arial"/>
+                <a:ea typeface="Arial"/>
+                <a:cs typeface="Arial"/>
+              </a:defRPr>
+            </a:pPr>
+            <a:r>
+              <a:rPr sz="1875" b="0">
+                <a:solidFill>
+                  <a:srgbClr val="535C62"/>
+                </a:solidFill>
+                <a:latin typeface="Arial"/>
+                <a:ea typeface="Arial"/>
+                <a:cs typeface="Arial"/>
+              </a:rPr>
+              <a:t>cenários iniciais</a:t>
+            </a:r>
+          </a:p>
+        </p:txBody>
+      </p:sp>
+      <p:sp>
+        <p:nvSpPr>
+          <p:cNvPr id="11" name="">
+            <a:extLst xmlns:a="http://schemas.openxmlformats.org/drawingml/2006/main">
+              <a:ext uri="{FF2B5EF4-FFF2-40B4-BE49-F238E27FC236}">
+                <a16:creationId xmlns:a16="http://schemas.microsoft.com/office/drawing/2014/main" id="{AE52C3FF-DB8A-422F-B528-AF4041E47B7D}"/>
+              </a:ext>
+            </a:extLst>
+          </p:cNvPr>
+          <p:cNvSpPr>
+            <a:spLocks xmlns:a="http://schemas.openxmlformats.org/drawingml/2006/main" noGrp="1"/>
+          </p:cNvSpPr>
+          <p:nvPr/>
+        </p:nvSpPr>
+        <p:spPr>
+          <a:xfrm xmlns:a="http://schemas.openxmlformats.org/drawingml/2006/main">
+            <a:off x="8286750" y="2695575"/>
+            <a:ext cx="3143250" cy="762000"/>
+          </a:xfrm>
+          <a:prstGeom xmlns:a="http://schemas.openxmlformats.org/drawingml/2006/main" prst="rect">
+            <a:avLst/>
+          </a:prstGeom>
+          <a:noFill xmlns:a="http://schemas.openxmlformats.org/drawingml/2006/main"/>
+          <a:ln xmlns:a="http://schemas.openxmlformats.org/drawingml/2006/main" w="0">
+            <a:noFill/>
+          </a:ln>
+        </p:spPr>
+        <p:txBody>
+          <a:bodyPr xmlns:a="http://schemas.openxmlformats.org/drawingml/2006/main">
+            <a:noAutofit/>
+          </a:bodyPr>
+          <a:lstStyle xmlns:a="http://schemas.openxmlformats.org/drawingml/2006/main"/>
+          <a:p xmlns:a="http://schemas.openxmlformats.org/drawingml/2006/main">
+            <a:pPr>
+              <a:defRPr sz="4650" b="1">
+                <a:solidFill>
+                  <a:srgbClr val="426BA5"/>
+                </a:solidFill>
+                <a:latin typeface="Arial"/>
+                <a:ea typeface="Arial"/>
+                <a:cs typeface="Arial"/>
+              </a:defRPr>
+            </a:pPr>
+            <a:r>
+              <a:rPr sz="4650" b="1">
+                <a:solidFill>
+                  <a:srgbClr val="426BA5"/>
+                </a:solidFill>
+                <a:latin typeface="Arial"/>
+                <a:ea typeface="Arial"/>
+                <a:cs typeface="Arial"/>
+              </a:rPr>
+              <a:t>80</a:t>
+            </a:r>
+          </a:p>
+        </p:txBody>
+      </p:sp>
+      <p:sp>
+        <p:nvSpPr>
+          <p:cNvPr id="12" name="">
+            <a:extLst xmlns:a="http://schemas.openxmlformats.org/drawingml/2006/main">
+              <a:ext uri="{FF2B5EF4-FFF2-40B4-BE49-F238E27FC236}">
+                <a16:creationId xmlns:a16="http://schemas.microsoft.com/office/drawing/2014/main" id="{C028FACE-DCBE-41BA-AD9E-4FB7A8CDAC9B}"/>
+              </a:ext>
+            </a:extLst>
+          </p:cNvPr>
+          <p:cNvSpPr>
+            <a:spLocks xmlns:a="http://schemas.openxmlformats.org/drawingml/2006/main" noGrp="1"/>
+          </p:cNvSpPr>
+          <p:nvPr/>
+        </p:nvSpPr>
+        <p:spPr>
+          <a:xfrm xmlns:a="http://schemas.openxmlformats.org/drawingml/2006/main">
+            <a:off x="8286750" y="3495675"/>
+            <a:ext cx="3190875" cy="428625"/>
+          </a:xfrm>
+          <a:prstGeom xmlns:a="http://schemas.openxmlformats.org/drawingml/2006/main" prst="rect">
+            <a:avLst/>
+          </a:prstGeom>
+          <a:noFill xmlns:a="http://schemas.openxmlformats.org/drawingml/2006/main"/>
+          <a:ln xmlns:a="http://schemas.openxmlformats.org/drawingml/2006/main" w="0">
+            <a:noFill/>
+          </a:ln>
+        </p:spPr>
+        <p:txBody>
+          <a:bodyPr xmlns:a="http://schemas.openxmlformats.org/drawingml/2006/main">
+            <a:noAutofit/>
+          </a:bodyPr>
+          <a:lstStyle xmlns:a="http://schemas.openxmlformats.org/drawingml/2006/main"/>
+          <a:p xmlns:a="http://schemas.openxmlformats.org/drawingml/2006/main">
+            <a:pPr>
+              <a:defRPr sz="1875" b="0">
+                <a:solidFill>
+                  <a:srgbClr val="535C62"/>
+                </a:solidFill>
+                <a:latin typeface="Arial"/>
+                <a:ea typeface="Arial"/>
+                <a:cs typeface="Arial"/>
+              </a:defRPr>
+            </a:pPr>
+            <a:r>
+              <a:rPr sz="1875" b="0">
+                <a:solidFill>
+                  <a:srgbClr val="535C62"/>
+                </a:solidFill>
+                <a:latin typeface="Arial"/>
+                <a:ea typeface="Arial"/>
+                <a:cs typeface="Arial"/>
+              </a:rPr>
+              <a:t>passos por execução</a:t>
             </a:r>
           </a:p>
         </p:txBody>
@@ -2569,6 +2839,7 @@
           <a:lstStyle xmlns:a="http://schemas.openxmlformats.org/drawingml/2006/main"/>
           <a:p xmlns:a="http://schemas.openxmlformats.org/drawingml/2006/main">
             <a:pPr>
+              <a:buNone/>
               <a:defRPr sz="3300" b="1">
                 <a:solidFill>
                   <a:srgbClr val="202428"/>
@@ -2626,6 +2897,7 @@
           <a:lstStyle xmlns:a="http://schemas.openxmlformats.org/drawingml/2006/main"/>
           <a:p xmlns:a="http://schemas.openxmlformats.org/drawingml/2006/main">
             <a:pPr>
+              <a:buNone/>
               <a:defRPr sz="1425" b="0">
                 <a:solidFill>
                   <a:srgbClr val="535C62"/>
@@ -2683,7 +2955,8 @@
           <a:lstStyle xmlns:a="http://schemas.openxmlformats.org/drawingml/2006/main"/>
           <a:p xmlns:a="http://schemas.openxmlformats.org/drawingml/2006/main">
             <a:pPr>
-              <a:defRPr sz="2400" b="1">
+              <a:buNone/>
+              <a:defRPr sz="2475" b="1">
                 <a:solidFill>
                   <a:srgbClr val="426BA5"/>
                 </a:solidFill>
@@ -2693,7 +2966,7 @@
               </a:defRPr>
             </a:pPr>
             <a:r>
-              <a:rPr sz="2400" b="1">
+              <a:rPr sz="2475" b="1">
                 <a:solidFill>
                   <a:srgbClr val="426BA5"/>
                 </a:solidFill>
@@ -2740,7 +3013,8 @@
           <a:lstStyle xmlns:a="http://schemas.openxmlformats.org/drawingml/2006/main"/>
           <a:p xmlns:a="http://schemas.openxmlformats.org/drawingml/2006/main">
             <a:pPr>
-              <a:defRPr sz="2100" b="0">
+              <a:buNone/>
+              <a:defRPr sz="2025" b="0">
                 <a:solidFill>
                   <a:srgbClr val="202428"/>
                 </a:solidFill>
@@ -2750,7 +3024,7 @@
               </a:defRPr>
             </a:pPr>
             <a:r>
-              <a:rPr sz="2100" b="0">
+              <a:rPr sz="2025" b="0">
                 <a:solidFill>
                   <a:srgbClr val="202428"/>
                 </a:solidFill>
@@ -2763,6 +3037,7 @@
           </a:p>
           <a:p xmlns:a="http://schemas.openxmlformats.org/drawingml/2006/main">
             <a:pPr>
+              <a:buNone/>
               <a:defRPr sz="2100" b="0">
                 <a:solidFill>
                   <a:srgbClr val="202428"/>
@@ -2781,12 +3056,13 @@
                 <a:ea typeface="Arial"/>
                 <a:cs typeface="Arial"/>
               </a:rPr>
-              <a:t>Limpo: sorteia um caminho livre.</a:t>
+              <a:t/>
             </a:r>
           </a:p>
           <a:p xmlns:a="http://schemas.openxmlformats.org/drawingml/2006/main">
             <a:pPr>
-              <a:defRPr sz="2100" b="0">
+              <a:buNone/>
+              <a:defRPr sz="2025" b="0">
                 <a:solidFill>
                   <a:srgbClr val="202428"/>
                 </a:solidFill>
@@ -2796,7 +3072,31 @@
               </a:defRPr>
             </a:pPr>
             <a:r>
-              <a:rPr sz="2100" b="0">
+              <a:rPr sz="2025" b="0">
+                <a:solidFill>
+                  <a:srgbClr val="202428"/>
+                </a:solidFill>
+                <a:latin typeface="Arial"/>
+                <a:ea typeface="Arial"/>
+                <a:cs typeface="Arial"/>
+              </a:rPr>
+              <a:t>Limpo: sorteia um caminho livre.</a:t>
+            </a:r>
+          </a:p>
+          <a:p xmlns:a="http://schemas.openxmlformats.org/drawingml/2006/main">
+            <a:pPr>
+              <a:buNone/>
+              <a:defRPr sz="2025" b="0">
+                <a:solidFill>
+                  <a:srgbClr val="202428"/>
+                </a:solidFill>
+                <a:latin typeface="Arial"/>
+                <a:ea typeface="Arial"/>
+                <a:cs typeface="Arial"/>
+              </a:defRPr>
+            </a:pPr>
+            <a:r>
+              <a:rPr sz="2025" b="0">
                 <a:solidFill>
                   <a:srgbClr val="202428"/>
                 </a:solidFill>
@@ -2843,7 +3143,8 @@
           <a:lstStyle xmlns:a="http://schemas.openxmlformats.org/drawingml/2006/main"/>
           <a:p xmlns:a="http://schemas.openxmlformats.org/drawingml/2006/main">
             <a:pPr>
-              <a:defRPr sz="2400" b="1">
+              <a:buNone/>
+              <a:defRPr sz="2475" b="1">
                 <a:solidFill>
                   <a:srgbClr val="137968"/>
                 </a:solidFill>
@@ -2853,7 +3154,7 @@
               </a:defRPr>
             </a:pPr>
             <a:r>
-              <a:rPr sz="2400" b="1">
+              <a:rPr sz="2475" b="1">
                 <a:solidFill>
                   <a:srgbClr val="137968"/>
                 </a:solidFill>
@@ -2900,7 +3201,8 @@
           <a:lstStyle xmlns:a="http://schemas.openxmlformats.org/drawingml/2006/main"/>
           <a:p xmlns:a="http://schemas.openxmlformats.org/drawingml/2006/main">
             <a:pPr>
-              <a:defRPr sz="2100" b="0">
+              <a:buNone/>
+              <a:defRPr sz="2025" b="0">
                 <a:solidFill>
                   <a:srgbClr val="202428"/>
                 </a:solidFill>
@@ -2910,7 +3212,7 @@
               </a:defRPr>
             </a:pPr>
             <a:r>
-              <a:rPr sz="2100" b="0">
+              <a:rPr sz="2025" b="0">
                 <a:solidFill>
                   <a:srgbClr val="202428"/>
                 </a:solidFill>
@@ -2923,6 +3225,7 @@
           </a:p>
           <a:p xmlns:a="http://schemas.openxmlformats.org/drawingml/2006/main">
             <a:pPr>
+              <a:buNone/>
               <a:defRPr sz="2100" b="0">
                 <a:solidFill>
                   <a:srgbClr val="202428"/>
@@ -2941,12 +3244,13 @@
                 <a:ea typeface="Arial"/>
                 <a:cs typeface="Arial"/>
               </a:rPr>
-              <a:t>Limpo: escolhe o vizinho menos visitado.</a:t>
+              <a:t/>
             </a:r>
           </a:p>
           <a:p xmlns:a="http://schemas.openxmlformats.org/drawingml/2006/main">
             <a:pPr>
-              <a:defRPr sz="2100" b="0">
+              <a:buNone/>
+              <a:defRPr sz="2025" b="0">
                 <a:solidFill>
                   <a:srgbClr val="202428"/>
                 </a:solidFill>
@@ -2956,7 +3260,31 @@
               </a:defRPr>
             </a:pPr>
             <a:r>
-              <a:rPr sz="2100" b="0">
+              <a:rPr sz="2025" b="0">
+                <a:solidFill>
+                  <a:srgbClr val="202428"/>
+                </a:solidFill>
+                <a:latin typeface="Arial"/>
+                <a:ea typeface="Arial"/>
+                <a:cs typeface="Arial"/>
+              </a:rPr>
+              <a:t>Limpo: prefere o vizinho menos visitado.</a:t>
+            </a:r>
+          </a:p>
+          <a:p xmlns:a="http://schemas.openxmlformats.org/drawingml/2006/main">
+            <a:pPr>
+              <a:buNone/>
+              <a:defRPr sz="2025" b="0">
+                <a:solidFill>
+                  <a:srgbClr val="202428"/>
+                </a:solidFill>
+                <a:latin typeface="Arial"/>
+                <a:ea typeface="Arial"/>
+                <a:cs typeface="Arial"/>
+              </a:defRPr>
+            </a:pPr>
+            <a:r>
+              <a:rPr sz="2025" b="0">
                 <a:solidFill>
                   <a:srgbClr val="202428"/>
                 </a:solidFill>
@@ -3003,9 +3331,10 @@
           <a:lstStyle xmlns:a="http://schemas.openxmlformats.org/drawingml/2006/main"/>
           <a:p xmlns:a="http://schemas.openxmlformats.org/drawingml/2006/main">
             <a:pPr>
-              <a:defRPr sz="2250" b="1">
-                <a:solidFill>
-                  <a:srgbClr val="202428"/>
+              <a:buNone/>
+              <a:defRPr sz="2175" b="1">
+                <a:solidFill>
+                  <a:srgbClr val="137968"/>
                 </a:solidFill>
                 <a:latin typeface="Arial"/>
                 <a:ea typeface="Arial"/>
@@ -3013,9 +3342,9 @@
               </a:defRPr>
             </a:pPr>
             <a:r>
-              <a:rPr sz="2250" b="1">
-                <a:solidFill>
-                  <a:srgbClr val="202428"/>
+              <a:rPr sz="2175" b="1">
+                <a:solidFill>
+                  <a:srgbClr val="137968"/>
                 </a:solidFill>
                 <a:latin typeface="Arial"/>
                 <a:ea typeface="Arial"/>
@@ -3060,6 +3389,7 @@
           <a:lstStyle xmlns:a="http://schemas.openxmlformats.org/drawingml/2006/main"/>
           <a:p xmlns:a="http://schemas.openxmlformats.org/drawingml/2006/main">
             <a:pPr>
+              <a:buNone/>
               <a:defRPr sz="2100" b="0">
                 <a:solidFill>
                   <a:srgbClr val="202428"/>
@@ -3083,6 +3413,7 @@
           </a:p>
           <a:p xmlns:a="http://schemas.openxmlformats.org/drawingml/2006/main">
             <a:pPr>
+              <a:buNone/>
               <a:defRPr sz="2100" b="0">
                 <a:solidFill>
                   <a:srgbClr val="202428"/>
@@ -3105,6 +3436,36 @@
             </a:r>
           </a:p>
         </p:txBody>
+      </p:sp>
+      <p:sp>
+        <p:nvSpPr>
+          <p:cNvPr id="10" name="">
+            <a:extLst xmlns:a="http://schemas.openxmlformats.org/drawingml/2006/main">
+              <a:ext uri="{FF2B5EF4-FFF2-40B4-BE49-F238E27FC236}">
+                <a16:creationId xmlns:a16="http://schemas.microsoft.com/office/drawing/2014/main" id="{FCCD1963-F6BF-49AA-AD13-FDFD56E98BCC}"/>
+              </a:ext>
+            </a:extLst>
+          </p:cNvPr>
+          <p:cNvSpPr>
+            <a:spLocks xmlns:a="http://schemas.openxmlformats.org/drawingml/2006/main" noGrp="1"/>
+          </p:cNvSpPr>
+          <p:nvPr/>
+        </p:nvSpPr>
+        <p:spPr>
+          <a:xfrm xmlns:a="http://schemas.openxmlformats.org/drawingml/2006/main">
+            <a:off x="685800" y="1276350"/>
+            <a:ext cx="10820400" cy="0"/>
+          </a:xfrm>
+          <a:prstGeom xmlns:a="http://schemas.openxmlformats.org/drawingml/2006/main" prst="line">
+            <a:avLst/>
+          </a:prstGeom>
+          <a:noFill xmlns:a="http://schemas.openxmlformats.org/drawingml/2006/main"/>
+          <a:ln xmlns:a="http://schemas.openxmlformats.org/drawingml/2006/main" w="9525">
+            <a:solidFill>
+              <a:srgbClr val="DDE5E8"/>
+            </a:solidFill>
+          </a:ln>
+        </p:spPr>
       </p:sp>
     </p:spTree>
     <p:extLst>
@@ -3169,6 +3530,7 @@
           <a:lstStyle xmlns:a="http://schemas.openxmlformats.org/drawingml/2006/main"/>
           <a:p xmlns:a="http://schemas.openxmlformats.org/drawingml/2006/main">
             <a:pPr>
+              <a:buNone/>
               <a:defRPr sz="3300" b="1">
                 <a:solidFill>
                   <a:srgbClr val="202428"/>
@@ -3226,6 +3588,7 @@
           <a:lstStyle xmlns:a="http://schemas.openxmlformats.org/drawingml/2006/main"/>
           <a:p xmlns:a="http://schemas.openxmlformats.org/drawingml/2006/main">
             <a:pPr>
+              <a:buNone/>
               <a:defRPr sz="1425" b="0">
                 <a:solidFill>
                   <a:srgbClr val="535C62"/>
@@ -3283,7 +3646,8 @@
           <a:lstStyle xmlns:a="http://schemas.openxmlformats.org/drawingml/2006/main"/>
           <a:p xmlns:a="http://schemas.openxmlformats.org/drawingml/2006/main">
             <a:pPr>
-              <a:defRPr sz="2475" b="1">
+              <a:buNone/>
+              <a:defRPr sz="2625" b="1">
                 <a:solidFill>
                   <a:srgbClr val="426BA5"/>
                 </a:solidFill>
@@ -3293,7 +3657,7 @@
               </a:defRPr>
             </a:pPr>
             <a:r>
-              <a:rPr sz="2475" b="1">
+              <a:rPr sz="2625" b="1">
                 <a:solidFill>
                   <a:srgbClr val="426BA5"/>
                 </a:solidFill>
@@ -3340,6 +3704,7 @@
           <a:lstStyle xmlns:a="http://schemas.openxmlformats.org/drawingml/2006/main"/>
           <a:p xmlns:a="http://schemas.openxmlformats.org/drawingml/2006/main">
             <a:pPr>
+              <a:buNone/>
               <a:defRPr sz="2250" b="0">
                 <a:solidFill>
                   <a:srgbClr val="202428"/>
@@ -3363,6 +3728,7 @@
           </a:p>
           <a:p xmlns:a="http://schemas.openxmlformats.org/drawingml/2006/main">
             <a:pPr>
+              <a:buNone/>
               <a:defRPr sz="2250" b="0">
                 <a:solidFill>
                   <a:srgbClr val="202428"/>
@@ -3420,7 +3786,8 @@
           <a:lstStyle xmlns:a="http://schemas.openxmlformats.org/drawingml/2006/main"/>
           <a:p xmlns:a="http://schemas.openxmlformats.org/drawingml/2006/main">
             <a:pPr>
-              <a:defRPr sz="2475" b="1">
+              <a:buNone/>
+              <a:defRPr sz="2625" b="1">
                 <a:solidFill>
                   <a:srgbClr val="137968"/>
                 </a:solidFill>
@@ -3430,7 +3797,7 @@
               </a:defRPr>
             </a:pPr>
             <a:r>
-              <a:rPr sz="2475" b="1">
+              <a:rPr sz="2625" b="1">
                 <a:solidFill>
                   <a:srgbClr val="137968"/>
                 </a:solidFill>
@@ -3477,6 +3844,7 @@
           <a:lstStyle xmlns:a="http://schemas.openxmlformats.org/drawingml/2006/main"/>
           <a:p xmlns:a="http://schemas.openxmlformats.org/drawingml/2006/main">
             <a:pPr>
+              <a:buNone/>
               <a:defRPr sz="2100" b="0">
                 <a:solidFill>
                   <a:srgbClr val="202428"/>
@@ -3500,6 +3868,7 @@
           </a:p>
           <a:p xmlns:a="http://schemas.openxmlformats.org/drawingml/2006/main">
             <a:pPr>
+              <a:buNone/>
               <a:defRPr sz="2100" b="0">
                 <a:solidFill>
                   <a:srgbClr val="202428"/>
@@ -3557,6 +3926,7 @@
           <a:lstStyle xmlns:a="http://schemas.openxmlformats.org/drawingml/2006/main"/>
           <a:p xmlns:a="http://schemas.openxmlformats.org/drawingml/2006/main">
             <a:pPr>
+              <a:buNone/>
               <a:defRPr sz="1725" b="0">
                 <a:solidFill>
                   <a:srgbClr val="535C62"/>
@@ -3579,6 +3949,36 @@
             </a:r>
           </a:p>
         </p:txBody>
+      </p:sp>
+      <p:sp>
+        <p:nvSpPr>
+          <p:cNvPr id="9" name="">
+            <a:extLst xmlns:a="http://schemas.openxmlformats.org/drawingml/2006/main">
+              <a:ext uri="{FF2B5EF4-FFF2-40B4-BE49-F238E27FC236}">
+                <a16:creationId xmlns:a16="http://schemas.microsoft.com/office/drawing/2014/main" id="{36A0B44B-4115-4278-99A8-C57D4663D980}"/>
+              </a:ext>
+            </a:extLst>
+          </p:cNvPr>
+          <p:cNvSpPr>
+            <a:spLocks xmlns:a="http://schemas.openxmlformats.org/drawingml/2006/main" noGrp="1"/>
+          </p:cNvSpPr>
+          <p:nvPr/>
+        </p:nvSpPr>
+        <p:spPr>
+          <a:xfrm xmlns:a="http://schemas.openxmlformats.org/drawingml/2006/main">
+            <a:off x="685800" y="1276350"/>
+            <a:ext cx="10820400" cy="0"/>
+          </a:xfrm>
+          <a:prstGeom xmlns:a="http://schemas.openxmlformats.org/drawingml/2006/main" prst="line">
+            <a:avLst/>
+          </a:prstGeom>
+          <a:noFill xmlns:a="http://schemas.openxmlformats.org/drawingml/2006/main"/>
+          <a:ln xmlns:a="http://schemas.openxmlformats.org/drawingml/2006/main" w="9525">
+            <a:solidFill>
+              <a:srgbClr val="DDE5E8"/>
+            </a:solidFill>
+          </a:ln>
+        </p:spPr>
       </p:sp>
     </p:spTree>
     <p:extLst>
@@ -3643,6 +4043,7 @@
           <a:lstStyle xmlns:a="http://schemas.openxmlformats.org/drawingml/2006/main"/>
           <a:p xmlns:a="http://schemas.openxmlformats.org/drawingml/2006/main">
             <a:pPr>
+              <a:buNone/>
               <a:defRPr sz="3300" b="1">
                 <a:solidFill>
                   <a:srgbClr val="202428"/>
@@ -3700,6 +4101,7 @@
           <a:lstStyle xmlns:a="http://schemas.openxmlformats.org/drawingml/2006/main"/>
           <a:p xmlns:a="http://schemas.openxmlformats.org/drawingml/2006/main">
             <a:pPr>
+              <a:buNone/>
               <a:defRPr sz="1425" b="0">
                 <a:solidFill>
                   <a:srgbClr val="535C62"/>
@@ -3725,7 +4127,7 @@
       </p:sp>
       <p:graphicFrame>
         <p:nvGraphicFramePr>
-          <p:cNvPr id="8" name=""/>
+          <p:cNvPr id="13" name=""/>
           <p:cNvGraphicFramePr/>
           <p:nvPr/>
         </p:nvGraphicFramePr>
@@ -3754,7 +4156,7 @@
                       <a:r>
                         <a:rPr sz="1800" b="1">
                           <a:solidFill>
-                            <a:srgbClr val="202428"/>
+                            <a:srgbClr val="FFFFFF"/>
                           </a:solidFill>
                           <a:latin typeface="Arial"/>
                           <a:ea typeface="Arial"/>
@@ -3764,9 +4166,9 @@
                       </a:r>
                     </a:p>
                   </a:txBody>
-                  <a:tcPr marL="114300" marR="76200" marT="95250" marB="76200">
+                  <a:tcPr marL="114300" marR="95250" marT="95250" marB="76200">
                     <a:solidFill>
-                      <a:srgbClr val="E8EEF3"/>
+                      <a:srgbClr val="426BA5"/>
                     </a:solidFill>
                   </a:tcPr>
                 </a:tc>
@@ -3778,7 +4180,7 @@
                       <a:r>
                         <a:rPr sz="1800" b="1">
                           <a:solidFill>
-                            <a:srgbClr val="202428"/>
+                            <a:srgbClr val="FFFFFF"/>
                           </a:solidFill>
                           <a:latin typeface="Arial"/>
                           <a:ea typeface="Arial"/>
@@ -3788,9 +4190,9 @@
                       </a:r>
                     </a:p>
                   </a:txBody>
-                  <a:tcPr marL="114300" marR="76200" marT="95250" marB="76200">
+                  <a:tcPr marL="114300" marR="95250" marT="95250" marB="76200">
                     <a:solidFill>
-                      <a:srgbClr val="E8EEF3"/>
+                      <a:srgbClr val="426BA5"/>
                     </a:solidFill>
                   </a:tcPr>
                 </a:tc>
@@ -3802,7 +4204,7 @@
                       <a:r>
                         <a:rPr sz="1800" b="1">
                           <a:solidFill>
-                            <a:srgbClr val="202428"/>
+                            <a:srgbClr val="FFFFFF"/>
                           </a:solidFill>
                           <a:latin typeface="Arial"/>
                           <a:ea typeface="Arial"/>
@@ -3812,9 +4214,9 @@
                       </a:r>
                     </a:p>
                   </a:txBody>
-                  <a:tcPr marL="114300" marR="76200" marT="95250" marB="76200">
+                  <a:tcPr marL="114300" marR="95250" marT="95250" marB="76200">
                     <a:solidFill>
-                      <a:srgbClr val="E8EEF3"/>
+                      <a:srgbClr val="426BA5"/>
                     </a:solidFill>
                   </a:tcPr>
                 </a:tc>
@@ -3826,7 +4228,7 @@
                       <a:r>
                         <a:rPr sz="1800" b="1">
                           <a:solidFill>
-                            <a:srgbClr val="202428"/>
+                            <a:srgbClr val="FFFFFF"/>
                           </a:solidFill>
                           <a:latin typeface="Arial"/>
                           <a:ea typeface="Arial"/>
@@ -3836,9 +4238,9 @@
                       </a:r>
                     </a:p>
                   </a:txBody>
-                  <a:tcPr marL="114300" marR="76200" marT="95250" marB="76200">
+                  <a:tcPr marL="114300" marR="95250" marT="95250" marB="76200">
                     <a:solidFill>
-                      <a:srgbClr val="E8EEF3"/>
+                      <a:srgbClr val="426BA5"/>
                     </a:solidFill>
                   </a:tcPr>
                 </a:tc>
@@ -3850,7 +4252,7 @@
                       <a:r>
                         <a:rPr sz="1800" b="1">
                           <a:solidFill>
-                            <a:srgbClr val="202428"/>
+                            <a:srgbClr val="FFFFFF"/>
                           </a:solidFill>
                           <a:latin typeface="Arial"/>
                           <a:ea typeface="Arial"/>
@@ -3860,9 +4262,9 @@
                       </a:r>
                     </a:p>
                   </a:txBody>
-                  <a:tcPr marL="114300" marR="76200" marT="95250" marB="76200">
+                  <a:tcPr marL="114300" marR="95250" marT="95250" marB="76200">
                     <a:solidFill>
-                      <a:srgbClr val="E8EEF3"/>
+                      <a:srgbClr val="426BA5"/>
                     </a:solidFill>
                   </a:tcPr>
                 </a:tc>
@@ -3874,7 +4276,7 @@
                       <a:r>
                         <a:rPr sz="1800" b="1">
                           <a:solidFill>
-                            <a:srgbClr val="202428"/>
+                            <a:srgbClr val="FFFFFF"/>
                           </a:solidFill>
                           <a:latin typeface="Arial"/>
                           <a:ea typeface="Arial"/>
@@ -3884,9 +4286,9 @@
                       </a:r>
                     </a:p>
                   </a:txBody>
-                  <a:tcPr marL="114300" marR="76200" marT="95250" marB="76200">
+                  <a:tcPr marL="114300" marR="95250" marT="95250" marB="76200">
                     <a:solidFill>
-                      <a:srgbClr val="E8EEF3"/>
+                      <a:srgbClr val="426BA5"/>
                     </a:solidFill>
                   </a:tcPr>
                 </a:tc>
@@ -3898,7 +4300,7 @@
                     <a:lstStyle/>
                     <a:p>
                       <a:r>
-                        <a:rPr sz="1800">
+                        <a:rPr sz="1800" b="0">
                           <a:solidFill>
                             <a:srgbClr val="202428"/>
                           </a:solidFill>
@@ -3910,7 +4312,7 @@
                       </a:r>
                     </a:p>
                   </a:txBody>
-                  <a:tcPr marL="114300" marR="76200" marT="95250" marB="76200">
+                  <a:tcPr marL="114300" marR="95250" marT="95250" marB="76200">
                     <a:solidFill>
                       <a:srgbClr val="FFFFFF"/>
                     </a:solidFill>
@@ -3922,9 +4324,9 @@
                     <a:lstStyle/>
                     <a:p>
                       <a:r>
-                        <a:rPr sz="1800">
+                        <a:rPr sz="1800" b="1">
                           <a:solidFill>
-                            <a:srgbClr val="202428"/>
+                            <a:srgbClr val="426BA5"/>
                           </a:solidFill>
                           <a:latin typeface="Arial"/>
                           <a:ea typeface="Arial"/>
@@ -3934,7 +4336,7 @@
                       </a:r>
                     </a:p>
                   </a:txBody>
-                  <a:tcPr marL="114300" marR="76200" marT="95250" marB="76200">
+                  <a:tcPr marL="114300" marR="95250" marT="95250" marB="76200">
                     <a:solidFill>
                       <a:srgbClr val="FFFFFF"/>
                     </a:solidFill>
@@ -3946,7 +4348,7 @@
                     <a:lstStyle/>
                     <a:p>
                       <a:r>
-                        <a:rPr sz="1800">
+                        <a:rPr sz="1800" b="0">
                           <a:solidFill>
                             <a:srgbClr val="202428"/>
                           </a:solidFill>
@@ -3958,7 +4360,7 @@
                       </a:r>
                     </a:p>
                   </a:txBody>
-                  <a:tcPr marL="114300" marR="76200" marT="95250" marB="76200">
+                  <a:tcPr marL="114300" marR="95250" marT="95250" marB="76200">
                     <a:solidFill>
                       <a:srgbClr val="FFFFFF"/>
                     </a:solidFill>
@@ -3970,7 +4372,7 @@
                     <a:lstStyle/>
                     <a:p>
                       <a:r>
-                        <a:rPr sz="1800">
+                        <a:rPr sz="1800" b="0">
                           <a:solidFill>
                             <a:srgbClr val="202428"/>
                           </a:solidFill>
@@ -3982,7 +4384,7 @@
                       </a:r>
                     </a:p>
                   </a:txBody>
-                  <a:tcPr marL="114300" marR="76200" marT="95250" marB="76200">
+                  <a:tcPr marL="114300" marR="95250" marT="95250" marB="76200">
                     <a:solidFill>
                       <a:srgbClr val="FFFFFF"/>
                     </a:solidFill>
@@ -3994,7 +4396,7 @@
                     <a:lstStyle/>
                     <a:p>
                       <a:r>
-                        <a:rPr sz="1800">
+                        <a:rPr sz="1800" b="0">
                           <a:solidFill>
                             <a:srgbClr val="202428"/>
                           </a:solidFill>
@@ -4006,7 +4408,7 @@
                       </a:r>
                     </a:p>
                   </a:txBody>
-                  <a:tcPr marL="114300" marR="76200" marT="95250" marB="76200">
+                  <a:tcPr marL="114300" marR="95250" marT="95250" marB="76200">
                     <a:solidFill>
                       <a:srgbClr val="FFFFFF"/>
                     </a:solidFill>
@@ -4018,7 +4420,7 @@
                     <a:lstStyle/>
                     <a:p>
                       <a:r>
-                        <a:rPr sz="1800">
+                        <a:rPr sz="1800" b="0">
                           <a:solidFill>
                             <a:srgbClr val="202428"/>
                           </a:solidFill>
@@ -4030,7 +4432,7 @@
                       </a:r>
                     </a:p>
                   </a:txBody>
-                  <a:tcPr marL="114300" marR="76200" marT="95250" marB="76200">
+                  <a:tcPr marL="114300" marR="95250" marT="95250" marB="76200">
                     <a:solidFill>
                       <a:srgbClr val="FFFFFF"/>
                     </a:solidFill>
@@ -4044,7 +4446,7 @@
                     <a:lstStyle/>
                     <a:p>
                       <a:r>
-                        <a:rPr sz="1800">
+                        <a:rPr sz="1800" b="0">
                           <a:solidFill>
                             <a:srgbClr val="202428"/>
                           </a:solidFill>
@@ -4056,9 +4458,9 @@
                       </a:r>
                     </a:p>
                   </a:txBody>
-                  <a:tcPr marL="114300" marR="76200" marT="95250" marB="76200">
+                  <a:tcPr marL="114300" marR="95250" marT="95250" marB="76200">
                     <a:solidFill>
-                      <a:srgbClr val="F2F7F5"/>
+                      <a:srgbClr val="F1F7F5"/>
                     </a:solidFill>
                   </a:tcPr>
                 </a:tc>
@@ -4068,9 +4470,9 @@
                     <a:lstStyle/>
                     <a:p>
                       <a:r>
-                        <a:rPr sz="1800">
+                        <a:rPr sz="1800" b="1">
                           <a:solidFill>
-                            <a:srgbClr val="202428"/>
+                            <a:srgbClr val="137968"/>
                           </a:solidFill>
                           <a:latin typeface="Arial"/>
                           <a:ea typeface="Arial"/>
@@ -4080,9 +4482,9 @@
                       </a:r>
                     </a:p>
                   </a:txBody>
-                  <a:tcPr marL="114300" marR="76200" marT="95250" marB="76200">
+                  <a:tcPr marL="114300" marR="95250" marT="95250" marB="76200">
                     <a:solidFill>
-                      <a:srgbClr val="F2F7F5"/>
+                      <a:srgbClr val="F1F7F5"/>
                     </a:solidFill>
                   </a:tcPr>
                 </a:tc>
@@ -4092,7 +4494,7 @@
                     <a:lstStyle/>
                     <a:p>
                       <a:r>
-                        <a:rPr sz="1800">
+                        <a:rPr sz="1800" b="0">
                           <a:solidFill>
                             <a:srgbClr val="202428"/>
                           </a:solidFill>
@@ -4104,9 +4506,9 @@
                       </a:r>
                     </a:p>
                   </a:txBody>
-                  <a:tcPr marL="114300" marR="76200" marT="95250" marB="76200">
+                  <a:tcPr marL="114300" marR="95250" marT="95250" marB="76200">
                     <a:solidFill>
-                      <a:srgbClr val="F2F7F5"/>
+                      <a:srgbClr val="F1F7F5"/>
                     </a:solidFill>
                   </a:tcPr>
                 </a:tc>
@@ -4116,7 +4518,7 @@
                     <a:lstStyle/>
                     <a:p>
                       <a:r>
-                        <a:rPr sz="1800">
+                        <a:rPr sz="1800" b="0">
                           <a:solidFill>
                             <a:srgbClr val="202428"/>
                           </a:solidFill>
@@ -4128,9 +4530,9 @@
                       </a:r>
                     </a:p>
                   </a:txBody>
-                  <a:tcPr marL="114300" marR="76200" marT="95250" marB="76200">
+                  <a:tcPr marL="114300" marR="95250" marT="95250" marB="76200">
                     <a:solidFill>
-                      <a:srgbClr val="F2F7F5"/>
+                      <a:srgbClr val="F1F7F5"/>
                     </a:solidFill>
                   </a:tcPr>
                 </a:tc>
@@ -4140,7 +4542,7 @@
                     <a:lstStyle/>
                     <a:p>
                       <a:r>
-                        <a:rPr sz="1800">
+                        <a:rPr sz="1800" b="0">
                           <a:solidFill>
                             <a:srgbClr val="202428"/>
                           </a:solidFill>
@@ -4152,9 +4554,9 @@
                       </a:r>
                     </a:p>
                   </a:txBody>
-                  <a:tcPr marL="114300" marR="76200" marT="95250" marB="76200">
+                  <a:tcPr marL="114300" marR="95250" marT="95250" marB="76200">
                     <a:solidFill>
-                      <a:srgbClr val="F2F7F5"/>
+                      <a:srgbClr val="F1F7F5"/>
                     </a:solidFill>
                   </a:tcPr>
                 </a:tc>
@@ -4164,7 +4566,7 @@
                     <a:lstStyle/>
                     <a:p>
                       <a:r>
-                        <a:rPr sz="1800">
+                        <a:rPr sz="1800" b="0">
                           <a:solidFill>
                             <a:srgbClr val="202428"/>
                           </a:solidFill>
@@ -4176,9 +4578,9 @@
                       </a:r>
                     </a:p>
                   </a:txBody>
-                  <a:tcPr marL="114300" marR="76200" marT="95250" marB="76200">
+                  <a:tcPr marL="114300" marR="95250" marT="95250" marB="76200">
                     <a:solidFill>
-                      <a:srgbClr val="F2F7F5"/>
+                      <a:srgbClr val="F1F7F5"/>
                     </a:solidFill>
                   </a:tcPr>
                 </a:tc>
@@ -4190,7 +4592,7 @@
                     <a:lstStyle/>
                     <a:p>
                       <a:r>
-                        <a:rPr sz="1800">
+                        <a:rPr sz="1800" b="0">
                           <a:solidFill>
                             <a:srgbClr val="202428"/>
                           </a:solidFill>
@@ -4202,7 +4604,7 @@
                       </a:r>
                     </a:p>
                   </a:txBody>
-                  <a:tcPr marL="114300" marR="76200" marT="95250" marB="76200">
+                  <a:tcPr marL="114300" marR="95250" marT="95250" marB="76200">
                     <a:solidFill>
                       <a:srgbClr val="FFFFFF"/>
                     </a:solidFill>
@@ -4214,9 +4616,9 @@
                     <a:lstStyle/>
                     <a:p>
                       <a:r>
-                        <a:rPr sz="1800">
+                        <a:rPr sz="1800" b="1">
                           <a:solidFill>
-                            <a:srgbClr val="202428"/>
+                            <a:srgbClr val="426BA5"/>
                           </a:solidFill>
                           <a:latin typeface="Arial"/>
                           <a:ea typeface="Arial"/>
@@ -4226,7 +4628,7 @@
                       </a:r>
                     </a:p>
                   </a:txBody>
-                  <a:tcPr marL="114300" marR="76200" marT="95250" marB="76200">
+                  <a:tcPr marL="114300" marR="95250" marT="95250" marB="76200">
                     <a:solidFill>
                       <a:srgbClr val="FFFFFF"/>
                     </a:solidFill>
@@ -4238,7 +4640,7 @@
                     <a:lstStyle/>
                     <a:p>
                       <a:r>
-                        <a:rPr sz="1800">
+                        <a:rPr sz="1800" b="0">
                           <a:solidFill>
                             <a:srgbClr val="202428"/>
                           </a:solidFill>
@@ -4250,7 +4652,7 @@
                       </a:r>
                     </a:p>
                   </a:txBody>
-                  <a:tcPr marL="114300" marR="76200" marT="95250" marB="76200">
+                  <a:tcPr marL="114300" marR="95250" marT="95250" marB="76200">
                     <a:solidFill>
                       <a:srgbClr val="FFFFFF"/>
                     </a:solidFill>
@@ -4262,7 +4664,7 @@
                     <a:lstStyle/>
                     <a:p>
                       <a:r>
-                        <a:rPr sz="1800">
+                        <a:rPr sz="1800" b="0">
                           <a:solidFill>
                             <a:srgbClr val="202428"/>
                           </a:solidFill>
@@ -4274,7 +4676,7 @@
                       </a:r>
                     </a:p>
                   </a:txBody>
-                  <a:tcPr marL="114300" marR="76200" marT="95250" marB="76200">
+                  <a:tcPr marL="114300" marR="95250" marT="95250" marB="76200">
                     <a:solidFill>
                       <a:srgbClr val="FFFFFF"/>
                     </a:solidFill>
@@ -4286,7 +4688,7 @@
                     <a:lstStyle/>
                     <a:p>
                       <a:r>
-                        <a:rPr sz="1800">
+                        <a:rPr sz="1800" b="0">
                           <a:solidFill>
                             <a:srgbClr val="202428"/>
                           </a:solidFill>
@@ -4298,7 +4700,7 @@
                       </a:r>
                     </a:p>
                   </a:txBody>
-                  <a:tcPr marL="114300" marR="76200" marT="95250" marB="76200">
+                  <a:tcPr marL="114300" marR="95250" marT="95250" marB="76200">
                     <a:solidFill>
                       <a:srgbClr val="FFFFFF"/>
                     </a:solidFill>
@@ -4310,7 +4712,7 @@
                     <a:lstStyle/>
                     <a:p>
                       <a:r>
-                        <a:rPr sz="1800">
+                        <a:rPr sz="1800" b="0">
                           <a:solidFill>
                             <a:srgbClr val="202428"/>
                           </a:solidFill>
@@ -4322,7 +4724,7 @@
                       </a:r>
                     </a:p>
                   </a:txBody>
-                  <a:tcPr marL="114300" marR="76200" marT="95250" marB="76200">
+                  <a:tcPr marL="114300" marR="95250" marT="95250" marB="76200">
                     <a:solidFill>
                       <a:srgbClr val="FFFFFF"/>
                     </a:solidFill>
@@ -4336,7 +4738,7 @@
                     <a:lstStyle/>
                     <a:p>
                       <a:r>
-                        <a:rPr sz="1800">
+                        <a:rPr sz="1800" b="0">
                           <a:solidFill>
                             <a:srgbClr val="202428"/>
                           </a:solidFill>
@@ -4348,9 +4750,9 @@
                       </a:r>
                     </a:p>
                   </a:txBody>
-                  <a:tcPr marL="114300" marR="76200" marT="95250" marB="76200">
+                  <a:tcPr marL="114300" marR="95250" marT="95250" marB="76200">
                     <a:solidFill>
-                      <a:srgbClr val="F2F7F5"/>
+                      <a:srgbClr val="F1F7F5"/>
                     </a:solidFill>
                   </a:tcPr>
                 </a:tc>
@@ -4360,9 +4762,9 @@
                     <a:lstStyle/>
                     <a:p>
                       <a:r>
-                        <a:rPr sz="1800">
+                        <a:rPr sz="1800" b="1">
                           <a:solidFill>
-                            <a:srgbClr val="202428"/>
+                            <a:srgbClr val="137968"/>
                           </a:solidFill>
                           <a:latin typeface="Arial"/>
                           <a:ea typeface="Arial"/>
@@ -4372,9 +4774,9 @@
                       </a:r>
                     </a:p>
                   </a:txBody>
-                  <a:tcPr marL="114300" marR="76200" marT="95250" marB="76200">
+                  <a:tcPr marL="114300" marR="95250" marT="95250" marB="76200">
                     <a:solidFill>
-                      <a:srgbClr val="F2F7F5"/>
+                      <a:srgbClr val="F1F7F5"/>
                     </a:solidFill>
                   </a:tcPr>
                 </a:tc>
@@ -4384,7 +4786,7 @@
                     <a:lstStyle/>
                     <a:p>
                       <a:r>
-                        <a:rPr sz="1800">
+                        <a:rPr sz="1800" b="0">
                           <a:solidFill>
                             <a:srgbClr val="202428"/>
                           </a:solidFill>
@@ -4396,9 +4798,9 @@
                       </a:r>
                     </a:p>
                   </a:txBody>
-                  <a:tcPr marL="114300" marR="76200" marT="95250" marB="76200">
+                  <a:tcPr marL="114300" marR="95250" marT="95250" marB="76200">
                     <a:solidFill>
-                      <a:srgbClr val="F2F7F5"/>
+                      <a:srgbClr val="F1F7F5"/>
                     </a:solidFill>
                   </a:tcPr>
                 </a:tc>
@@ -4408,7 +4810,7 @@
                     <a:lstStyle/>
                     <a:p>
                       <a:r>
-                        <a:rPr sz="1800">
+                        <a:rPr sz="1800" b="0">
                           <a:solidFill>
                             <a:srgbClr val="202428"/>
                           </a:solidFill>
@@ -4420,9 +4822,9 @@
                       </a:r>
                     </a:p>
                   </a:txBody>
-                  <a:tcPr marL="114300" marR="76200" marT="95250" marB="76200">
+                  <a:tcPr marL="114300" marR="95250" marT="95250" marB="76200">
                     <a:solidFill>
-                      <a:srgbClr val="F2F7F5"/>
+                      <a:srgbClr val="F1F7F5"/>
                     </a:solidFill>
                   </a:tcPr>
                 </a:tc>
@@ -4432,7 +4834,7 @@
                     <a:lstStyle/>
                     <a:p>
                       <a:r>
-                        <a:rPr sz="1800">
+                        <a:rPr sz="1800" b="0">
                           <a:solidFill>
                             <a:srgbClr val="202428"/>
                           </a:solidFill>
@@ -4444,9 +4846,9 @@
                       </a:r>
                     </a:p>
                   </a:txBody>
-                  <a:tcPr marL="114300" marR="76200" marT="95250" marB="76200">
+                  <a:tcPr marL="114300" marR="95250" marT="95250" marB="76200">
                     <a:solidFill>
-                      <a:srgbClr val="F2F7F5"/>
+                      <a:srgbClr val="F1F7F5"/>
                     </a:solidFill>
                   </a:tcPr>
                 </a:tc>
@@ -4456,7 +4858,7 @@
                     <a:lstStyle/>
                     <a:p>
                       <a:r>
-                        <a:rPr sz="1800">
+                        <a:rPr sz="1800" b="0">
                           <a:solidFill>
                             <a:srgbClr val="202428"/>
                           </a:solidFill>
@@ -4468,9 +4870,9 @@
                       </a:r>
                     </a:p>
                   </a:txBody>
-                  <a:tcPr marL="114300" marR="76200" marT="95250" marB="76200">
+                  <a:tcPr marL="114300" marR="95250" marT="95250" marB="76200">
                     <a:solidFill>
-                      <a:srgbClr val="F2F7F5"/>
+                      <a:srgbClr val="F1F7F5"/>
                     </a:solidFill>
                   </a:tcPr>
                 </a:tc>
@@ -4482,7 +4884,7 @@
                     <a:lstStyle/>
                     <a:p>
                       <a:r>
-                        <a:rPr sz="1800">
+                        <a:rPr sz="1800" b="0">
                           <a:solidFill>
                             <a:srgbClr val="202428"/>
                           </a:solidFill>
@@ -4494,7 +4896,7 @@
                       </a:r>
                     </a:p>
                   </a:txBody>
-                  <a:tcPr marL="114300" marR="76200" marT="95250" marB="76200">
+                  <a:tcPr marL="114300" marR="95250" marT="95250" marB="76200">
                     <a:solidFill>
                       <a:srgbClr val="FFFFFF"/>
                     </a:solidFill>
@@ -4506,9 +4908,9 @@
                     <a:lstStyle/>
                     <a:p>
                       <a:r>
-                        <a:rPr sz="1800">
+                        <a:rPr sz="1800" b="1">
                           <a:solidFill>
-                            <a:srgbClr val="202428"/>
+                            <a:srgbClr val="426BA5"/>
                           </a:solidFill>
                           <a:latin typeface="Arial"/>
                           <a:ea typeface="Arial"/>
@@ -4518,7 +4920,7 @@
                       </a:r>
                     </a:p>
                   </a:txBody>
-                  <a:tcPr marL="114300" marR="76200" marT="95250" marB="76200">
+                  <a:tcPr marL="114300" marR="95250" marT="95250" marB="76200">
                     <a:solidFill>
                       <a:srgbClr val="FFFFFF"/>
                     </a:solidFill>
@@ -4530,7 +4932,7 @@
                     <a:lstStyle/>
                     <a:p>
                       <a:r>
-                        <a:rPr sz="1800">
+                        <a:rPr sz="1800" b="0">
                           <a:solidFill>
                             <a:srgbClr val="202428"/>
                           </a:solidFill>
@@ -4542,7 +4944,7 @@
                       </a:r>
                     </a:p>
                   </a:txBody>
-                  <a:tcPr marL="114300" marR="76200" marT="95250" marB="76200">
+                  <a:tcPr marL="114300" marR="95250" marT="95250" marB="76200">
                     <a:solidFill>
                       <a:srgbClr val="FFFFFF"/>
                     </a:solidFill>
@@ -4554,7 +4956,7 @@
                     <a:lstStyle/>
                     <a:p>
                       <a:r>
-                        <a:rPr sz="1800">
+                        <a:rPr sz="1800" b="0">
                           <a:solidFill>
                             <a:srgbClr val="202428"/>
                           </a:solidFill>
@@ -4566,7 +4968,7 @@
                       </a:r>
                     </a:p>
                   </a:txBody>
-                  <a:tcPr marL="114300" marR="76200" marT="95250" marB="76200">
+                  <a:tcPr marL="114300" marR="95250" marT="95250" marB="76200">
                     <a:solidFill>
                       <a:srgbClr val="FFFFFF"/>
                     </a:solidFill>
@@ -4578,7 +4980,7 @@
                     <a:lstStyle/>
                     <a:p>
                       <a:r>
-                        <a:rPr sz="1800">
+                        <a:rPr sz="1800" b="0">
                           <a:solidFill>
                             <a:srgbClr val="202428"/>
                           </a:solidFill>
@@ -4590,7 +4992,7 @@
                       </a:r>
                     </a:p>
                   </a:txBody>
-                  <a:tcPr marL="114300" marR="76200" marT="95250" marB="76200">
+                  <a:tcPr marL="114300" marR="95250" marT="95250" marB="76200">
                     <a:solidFill>
                       <a:srgbClr val="FFFFFF"/>
                     </a:solidFill>
@@ -4602,7 +5004,7 @@
                     <a:lstStyle/>
                     <a:p>
                       <a:r>
-                        <a:rPr sz="1800">
+                        <a:rPr sz="1800" b="0">
                           <a:solidFill>
                             <a:srgbClr val="202428"/>
                           </a:solidFill>
@@ -4614,7 +5016,7 @@
                       </a:r>
                     </a:p>
                   </a:txBody>
-                  <a:tcPr marL="114300" marR="76200" marT="95250" marB="76200">
+                  <a:tcPr marL="114300" marR="95250" marT="95250" marB="76200">
                     <a:solidFill>
                       <a:srgbClr val="FFFFFF"/>
                     </a:solidFill>
@@ -4628,7 +5030,7 @@
                     <a:lstStyle/>
                     <a:p>
                       <a:r>
-                        <a:rPr sz="1800">
+                        <a:rPr sz="1800" b="0">
                           <a:solidFill>
                             <a:srgbClr val="202428"/>
                           </a:solidFill>
@@ -4640,9 +5042,9 @@
                       </a:r>
                     </a:p>
                   </a:txBody>
-                  <a:tcPr marL="114300" marR="76200" marT="95250" marB="76200">
+                  <a:tcPr marL="114300" marR="95250" marT="95250" marB="76200">
                     <a:solidFill>
-                      <a:srgbClr val="F2F7F5"/>
+                      <a:srgbClr val="F1F7F5"/>
                     </a:solidFill>
                   </a:tcPr>
                 </a:tc>
@@ -4652,9 +5054,9 @@
                     <a:lstStyle/>
                     <a:p>
                       <a:r>
-                        <a:rPr sz="1800">
+                        <a:rPr sz="1800" b="1">
                           <a:solidFill>
-                            <a:srgbClr val="202428"/>
+                            <a:srgbClr val="137968"/>
                           </a:solidFill>
                           <a:latin typeface="Arial"/>
                           <a:ea typeface="Arial"/>
@@ -4664,9 +5066,9 @@
                       </a:r>
                     </a:p>
                   </a:txBody>
-                  <a:tcPr marL="114300" marR="76200" marT="95250" marB="76200">
+                  <a:tcPr marL="114300" marR="95250" marT="95250" marB="76200">
                     <a:solidFill>
-                      <a:srgbClr val="F2F7F5"/>
+                      <a:srgbClr val="F1F7F5"/>
                     </a:solidFill>
                   </a:tcPr>
                 </a:tc>
@@ -4676,7 +5078,7 @@
                     <a:lstStyle/>
                     <a:p>
                       <a:r>
-                        <a:rPr sz="1800">
+                        <a:rPr sz="1800" b="0">
                           <a:solidFill>
                             <a:srgbClr val="202428"/>
                           </a:solidFill>
@@ -4688,9 +5090,9 @@
                       </a:r>
                     </a:p>
                   </a:txBody>
-                  <a:tcPr marL="114300" marR="76200" marT="95250" marB="76200">
+                  <a:tcPr marL="114300" marR="95250" marT="95250" marB="76200">
                     <a:solidFill>
-                      <a:srgbClr val="F2F7F5"/>
+                      <a:srgbClr val="F1F7F5"/>
                     </a:solidFill>
                   </a:tcPr>
                 </a:tc>
@@ -4700,7 +5102,7 @@
                     <a:lstStyle/>
                     <a:p>
                       <a:r>
-                        <a:rPr sz="1800">
+                        <a:rPr sz="1800" b="0">
                           <a:solidFill>
                             <a:srgbClr val="202428"/>
                           </a:solidFill>
@@ -4712,9 +5114,9 @@
                       </a:r>
                     </a:p>
                   </a:txBody>
-                  <a:tcPr marL="114300" marR="76200" marT="95250" marB="76200">
+                  <a:tcPr marL="114300" marR="95250" marT="95250" marB="76200">
                     <a:solidFill>
-                      <a:srgbClr val="F2F7F5"/>
+                      <a:srgbClr val="F1F7F5"/>
                     </a:solidFill>
                   </a:tcPr>
                 </a:tc>
@@ -4724,7 +5126,7 @@
                     <a:lstStyle/>
                     <a:p>
                       <a:r>
-                        <a:rPr sz="1800">
+                        <a:rPr sz="1800" b="0">
                           <a:solidFill>
                             <a:srgbClr val="202428"/>
                           </a:solidFill>
@@ -4736,9 +5138,9 @@
                       </a:r>
                     </a:p>
                   </a:txBody>
-                  <a:tcPr marL="114300" marR="76200" marT="95250" marB="76200">
+                  <a:tcPr marL="114300" marR="95250" marT="95250" marB="76200">
                     <a:solidFill>
-                      <a:srgbClr val="F2F7F5"/>
+                      <a:srgbClr val="F1F7F5"/>
                     </a:solidFill>
                   </a:tcPr>
                 </a:tc>
@@ -4748,7 +5150,7 @@
                     <a:lstStyle/>
                     <a:p>
                       <a:r>
-                        <a:rPr sz="1800">
+                        <a:rPr sz="1800" b="0">
                           <a:solidFill>
                             <a:srgbClr val="202428"/>
                           </a:solidFill>
@@ -4760,9 +5162,9 @@
                       </a:r>
                     </a:p>
                   </a:txBody>
-                  <a:tcPr marL="114300" marR="76200" marT="95250" marB="76200">
+                  <a:tcPr marL="114300" marR="95250" marT="95250" marB="76200">
                     <a:solidFill>
-                      <a:srgbClr val="F2F7F5"/>
+                      <a:srgbClr val="F1F7F5"/>
                     </a:solidFill>
                   </a:tcPr>
                 </a:tc>
@@ -4788,7 +5190,7 @@
         <p:spPr>
           <a:xfrm xmlns:a="http://schemas.openxmlformats.org/drawingml/2006/main">
             <a:off x="609600" y="5276850"/>
-            <a:ext cx="10972800" cy="400050"/>
+            <a:ext cx="5238750" cy="400050"/>
           </a:xfrm>
           <a:prstGeom xmlns:a="http://schemas.openxmlformats.org/drawingml/2006/main" prst="rect">
             <a:avLst/>
@@ -4805,9 +5207,10 @@
           <a:lstStyle xmlns:a="http://schemas.openxmlformats.org/drawingml/2006/main"/>
           <a:p xmlns:a="http://schemas.openxmlformats.org/drawingml/2006/main">
             <a:pPr>
-              <a:defRPr sz="2025" b="1">
-                <a:solidFill>
-                  <a:srgbClr val="202428"/>
+              <a:buNone/>
+              <a:defRPr sz="1950" b="1">
+                <a:solidFill>
+                  <a:srgbClr val="426BA5"/>
                 </a:solidFill>
                 <a:latin typeface="Arial"/>
                 <a:ea typeface="Arial"/>
@@ -4815,15 +5218,15 @@
               </a:defRPr>
             </a:pPr>
             <a:r>
-              <a:rPr sz="2025" b="1">
-                <a:solidFill>
-                  <a:srgbClr val="202428"/>
+              <a:rPr sz="1950" b="1">
+                <a:solidFill>
+                  <a:srgbClr val="426BA5"/>
                 </a:solidFill>
                 <a:latin typeface="Arial"/>
                 <a:ea typeface="Arial"/>
                 <a:cs typeface="Arial"/>
               </a:rPr>
-              <a:t>Médias: Pontos 1 / Pontos 2</a:t>
+              <a:t>Médias: Simples</a:t>
             </a:r>
           </a:p>
         </p:txBody>
@@ -4844,8 +5247,8 @@
         </p:nvSpPr>
         <p:spPr>
           <a:xfrm xmlns:a="http://schemas.openxmlformats.org/drawingml/2006/main">
-            <a:off x="609600" y="5772150"/>
-            <a:ext cx="10972800" cy="409575"/>
+            <a:off x="609600" y="5753100"/>
+            <a:ext cx="5286375" cy="409575"/>
           </a:xfrm>
           <a:prstGeom xmlns:a="http://schemas.openxmlformats.org/drawingml/2006/main" prst="rect">
             <a:avLst/>
@@ -4862,7 +5265,8 @@
           <a:lstStyle xmlns:a="http://schemas.openxmlformats.org/drawingml/2006/main"/>
           <a:p xmlns:a="http://schemas.openxmlformats.org/drawingml/2006/main">
             <a:pPr>
-              <a:defRPr sz="2025" b="0">
+              <a:buNone/>
+              <a:defRPr sz="1800" b="0">
                 <a:solidFill>
                   <a:srgbClr val="202428"/>
                 </a:solidFill>
@@ -4872,7 +5276,7 @@
               </a:defRPr>
             </a:pPr>
             <a:r>
-              <a:rPr sz="2025" b="0">
+              <a:rPr sz="1800" b="0">
                 <a:solidFill>
                   <a:srgbClr val="202428"/>
                 </a:solidFill>
@@ -4880,7 +5284,151 @@
                 <a:ea typeface="Arial"/>
                 <a:cs typeface="Arial"/>
               </a:rPr>
-              <a:t>Simples: 1064,00 / 987,67       Com memória: 1134,67 / 1058,67</a:t>
+              <a:t>Pontos 1: 1064,00     Pontos 2: 987,67</a:t>
+            </a:r>
+          </a:p>
+        </p:txBody>
+      </p:sp>
+      <p:sp>
+        <p:nvSpPr>
+          <p:cNvPr id="8" name="">
+            <a:extLst xmlns:a="http://schemas.openxmlformats.org/drawingml/2006/main">
+              <a:ext uri="{FF2B5EF4-FFF2-40B4-BE49-F238E27FC236}">
+                <a16:creationId xmlns:a16="http://schemas.microsoft.com/office/drawing/2014/main" id="{505ACF9F-CC44-4E92-8C70-4C13029F5DE4}"/>
+              </a:ext>
+            </a:extLst>
+          </p:cNvPr>
+          <p:cNvSpPr>
+            <a:spLocks xmlns:a="http://schemas.openxmlformats.org/drawingml/2006/main" noGrp="1"/>
+          </p:cNvSpPr>
+          <p:nvPr/>
+        </p:nvSpPr>
+        <p:spPr>
+          <a:xfrm xmlns:a="http://schemas.openxmlformats.org/drawingml/2006/main">
+            <a:off x="685800" y="1276350"/>
+            <a:ext cx="10820400" cy="0"/>
+          </a:xfrm>
+          <a:prstGeom xmlns:a="http://schemas.openxmlformats.org/drawingml/2006/main" prst="line">
+            <a:avLst/>
+          </a:prstGeom>
+          <a:noFill xmlns:a="http://schemas.openxmlformats.org/drawingml/2006/main"/>
+          <a:ln xmlns:a="http://schemas.openxmlformats.org/drawingml/2006/main" w="9525">
+            <a:solidFill>
+              <a:srgbClr val="DDE5E8"/>
+            </a:solidFill>
+          </a:ln>
+        </p:spPr>
+      </p:sp>
+      <p:sp>
+        <p:nvSpPr>
+          <p:cNvPr id="9" name="">
+            <a:extLst xmlns:a="http://schemas.openxmlformats.org/drawingml/2006/main">
+              <a:ext uri="{FF2B5EF4-FFF2-40B4-BE49-F238E27FC236}">
+                <a16:creationId xmlns:a16="http://schemas.microsoft.com/office/drawing/2014/main" id="{14809A05-6862-4C63-A2A5-96FC783A81E3}"/>
+              </a:ext>
+            </a:extLst>
+          </p:cNvPr>
+          <p:cNvSpPr>
+            <a:spLocks xmlns:a="http://schemas.openxmlformats.org/drawingml/2006/main" noGrp="1"/>
+          </p:cNvSpPr>
+          <p:nvPr/>
+        </p:nvSpPr>
+        <p:spPr>
+          <a:xfrm xmlns:a="http://schemas.openxmlformats.org/drawingml/2006/main">
+            <a:off x="6324600" y="5276850"/>
+            <a:ext cx="5257800" cy="400050"/>
+          </a:xfrm>
+          <a:prstGeom xmlns:a="http://schemas.openxmlformats.org/drawingml/2006/main" prst="rect">
+            <a:avLst/>
+          </a:prstGeom>
+          <a:noFill xmlns:a="http://schemas.openxmlformats.org/drawingml/2006/main"/>
+          <a:ln xmlns:a="http://schemas.openxmlformats.org/drawingml/2006/main" w="0">
+            <a:noFill/>
+          </a:ln>
+        </p:spPr>
+        <p:txBody>
+          <a:bodyPr xmlns:a="http://schemas.openxmlformats.org/drawingml/2006/main">
+            <a:noAutofit/>
+          </a:bodyPr>
+          <a:lstStyle xmlns:a="http://schemas.openxmlformats.org/drawingml/2006/main"/>
+          <a:p xmlns:a="http://schemas.openxmlformats.org/drawingml/2006/main">
+            <a:pPr>
+              <a:defRPr sz="1950" b="1">
+                <a:solidFill>
+                  <a:srgbClr val="137968"/>
+                </a:solidFill>
+                <a:latin typeface="Arial"/>
+                <a:ea typeface="Arial"/>
+                <a:cs typeface="Arial"/>
+              </a:defRPr>
+            </a:pPr>
+            <a:r>
+              <a:rPr sz="1950" b="1">
+                <a:solidFill>
+                  <a:srgbClr val="137968"/>
+                </a:solidFill>
+                <a:latin typeface="Arial"/>
+                <a:ea typeface="Arial"/>
+                <a:cs typeface="Arial"/>
+              </a:rPr>
+              <a:t>Médias: Com memória</a:t>
+            </a:r>
+          </a:p>
+        </p:txBody>
+      </p:sp>
+      <p:sp>
+        <p:nvSpPr>
+          <p:cNvPr id="10" name="">
+            <a:extLst xmlns:a="http://schemas.openxmlformats.org/drawingml/2006/main">
+              <a:ext uri="{FF2B5EF4-FFF2-40B4-BE49-F238E27FC236}">
+                <a16:creationId xmlns:a16="http://schemas.microsoft.com/office/drawing/2014/main" id="{7AD8C1AF-A2C2-4B2A-8F18-A747D1C9E5D0}"/>
+              </a:ext>
+            </a:extLst>
+          </p:cNvPr>
+          <p:cNvSpPr>
+            <a:spLocks xmlns:a="http://schemas.openxmlformats.org/drawingml/2006/main" noGrp="1"/>
+          </p:cNvSpPr>
+          <p:nvPr/>
+        </p:nvSpPr>
+        <p:spPr>
+          <a:xfrm xmlns:a="http://schemas.openxmlformats.org/drawingml/2006/main">
+            <a:off x="6324600" y="5753100"/>
+            <a:ext cx="5257800" cy="409575"/>
+          </a:xfrm>
+          <a:prstGeom xmlns:a="http://schemas.openxmlformats.org/drawingml/2006/main" prst="rect">
+            <a:avLst/>
+          </a:prstGeom>
+          <a:noFill xmlns:a="http://schemas.openxmlformats.org/drawingml/2006/main"/>
+          <a:ln xmlns:a="http://schemas.openxmlformats.org/drawingml/2006/main" w="0">
+            <a:noFill/>
+          </a:ln>
+        </p:spPr>
+        <p:txBody>
+          <a:bodyPr xmlns:a="http://schemas.openxmlformats.org/drawingml/2006/main">
+            <a:noAutofit/>
+          </a:bodyPr>
+          <a:lstStyle xmlns:a="http://schemas.openxmlformats.org/drawingml/2006/main"/>
+          <a:p xmlns:a="http://schemas.openxmlformats.org/drawingml/2006/main">
+            <a:pPr>
+              <a:defRPr sz="1800" b="0">
+                <a:solidFill>
+                  <a:srgbClr val="202428"/>
+                </a:solidFill>
+                <a:latin typeface="Arial"/>
+                <a:ea typeface="Arial"/>
+                <a:cs typeface="Arial"/>
+              </a:defRPr>
+            </a:pPr>
+            <a:r>
+              <a:rPr sz="1800" b="0">
+                <a:solidFill>
+                  <a:srgbClr val="202428"/>
+                </a:solidFill>
+                <a:latin typeface="Arial"/>
+                <a:ea typeface="Arial"/>
+                <a:cs typeface="Arial"/>
+              </a:rPr>
+              <a:t>Pontos 1: 1134,67     Pontos 2: 1058,67</a:t>
             </a:r>
           </a:p>
         </p:txBody>
@@ -4948,6 +5496,7 @@
           <a:lstStyle xmlns:a="http://schemas.openxmlformats.org/drawingml/2006/main"/>
           <a:p xmlns:a="http://schemas.openxmlformats.org/drawingml/2006/main">
             <a:pPr>
+              <a:buNone/>
               <a:defRPr sz="3300" b="1">
                 <a:solidFill>
                   <a:srgbClr val="202428"/>
@@ -5005,6 +5554,7 @@
           <a:lstStyle xmlns:a="http://schemas.openxmlformats.org/drawingml/2006/main"/>
           <a:p xmlns:a="http://schemas.openxmlformats.org/drawingml/2006/main">
             <a:pPr>
+              <a:buNone/>
               <a:defRPr sz="1425" b="0">
                 <a:solidFill>
                   <a:srgbClr val="535C62"/>
@@ -5030,7 +5580,7 @@
       </p:sp>
       <p:graphicFrame>
         <p:nvGraphicFramePr>
-          <p:cNvPr id="8" name="Chart"/>
+          <p:cNvPr id="12" name="Chart"/>
           <p:cNvGraphicFramePr/>
           <p:nvPr/>
         </p:nvGraphicFramePr>
@@ -5040,13 +5590,13 @@
         </p:xfrm>
         <a:graphic xmlns:a="http://schemas.openxmlformats.org/drawingml/2006/main">
           <a:graphicData uri="http://schemas.openxmlformats.org/drawingml/2006/chart">
-            <c:chart xmlns:r="http://schemas.openxmlformats.org/officeDocument/2006/relationships" xmlns:c="http://schemas.openxmlformats.org/drawingml/2006/chart" r:id="R3e1b792c45f34d77"/>
+            <c:chart xmlns:r="http://schemas.openxmlformats.org/officeDocument/2006/relationships" xmlns:c="http://schemas.openxmlformats.org/drawingml/2006/chart" r:id="R9e93513a50564504"/>
           </a:graphicData>
         </a:graphic>
       </p:graphicFrame>
       <p:graphicFrame>
         <p:nvGraphicFramePr>
-          <p:cNvPr id="9" name="Chart"/>
+          <p:cNvPr id="13" name="Chart"/>
           <p:cNvGraphicFramePr/>
           <p:nvPr/>
         </p:nvGraphicFramePr>
@@ -5056,7 +5606,7 @@
         </p:xfrm>
         <a:graphic xmlns:a="http://schemas.openxmlformats.org/drawingml/2006/main">
           <a:graphicData uri="http://schemas.openxmlformats.org/drawingml/2006/chart">
-            <c:chart xmlns:r="http://schemas.openxmlformats.org/officeDocument/2006/relationships" xmlns:c="http://schemas.openxmlformats.org/drawingml/2006/chart" r:id="R467bebac35644a8e"/>
+            <c:chart xmlns:r="http://schemas.openxmlformats.org/officeDocument/2006/relationships" xmlns:c="http://schemas.openxmlformats.org/drawingml/2006/chart" r:id="R3aa2182f5daa4f0d"/>
           </a:graphicData>
         </a:graphic>
       </p:graphicFrame>
@@ -5094,9 +5644,10 @@
           <a:lstStyle xmlns:a="http://schemas.openxmlformats.org/drawingml/2006/main"/>
           <a:p xmlns:a="http://schemas.openxmlformats.org/drawingml/2006/main">
             <a:pPr>
+              <a:buNone/>
               <a:defRPr sz="1950" b="1">
                 <a:solidFill>
-                  <a:srgbClr val="202428"/>
+                  <a:srgbClr val="137968"/>
                 </a:solidFill>
                 <a:latin typeface="Arial"/>
                 <a:ea typeface="Arial"/>
@@ -5106,7 +5657,7 @@
             <a:r>
               <a:rPr sz="1950" b="1">
                 <a:solidFill>
-                  <a:srgbClr val="202428"/>
+                  <a:srgbClr val="137968"/>
                 </a:solidFill>
                 <a:latin typeface="Arial"/>
                 <a:ea typeface="Arial"/>
@@ -5116,6 +5667,36 @@
             </a:r>
           </a:p>
         </p:txBody>
+      </p:sp>
+      <p:sp>
+        <p:nvSpPr>
+          <p:cNvPr id="9" name="">
+            <a:extLst xmlns:a="http://schemas.openxmlformats.org/drawingml/2006/main">
+              <a:ext uri="{FF2B5EF4-FFF2-40B4-BE49-F238E27FC236}">
+                <a16:creationId xmlns:a16="http://schemas.microsoft.com/office/drawing/2014/main" id="{3E592944-DA54-4381-8339-793C525759DE}"/>
+              </a:ext>
+            </a:extLst>
+          </p:cNvPr>
+          <p:cNvSpPr>
+            <a:spLocks xmlns:a="http://schemas.openxmlformats.org/drawingml/2006/main" noGrp="1"/>
+          </p:cNvSpPr>
+          <p:nvPr/>
+        </p:nvSpPr>
+        <p:spPr>
+          <a:xfrm xmlns:a="http://schemas.openxmlformats.org/drawingml/2006/main">
+            <a:off x="685800" y="1276350"/>
+            <a:ext cx="10820400" cy="0"/>
+          </a:xfrm>
+          <a:prstGeom xmlns:a="http://schemas.openxmlformats.org/drawingml/2006/main" prst="line">
+            <a:avLst/>
+          </a:prstGeom>
+          <a:noFill xmlns:a="http://schemas.openxmlformats.org/drawingml/2006/main"/>
+          <a:ln xmlns:a="http://schemas.openxmlformats.org/drawingml/2006/main" w="9525">
+            <a:solidFill>
+              <a:srgbClr val="DDE5E8"/>
+            </a:solidFill>
+          </a:ln>
+        </p:spPr>
       </p:sp>
     </p:spTree>
     <p:extLst>
@@ -5180,6 +5761,7 @@
           <a:lstStyle xmlns:a="http://schemas.openxmlformats.org/drawingml/2006/main"/>
           <a:p xmlns:a="http://schemas.openxmlformats.org/drawingml/2006/main">
             <a:pPr>
+              <a:buNone/>
               <a:defRPr sz="3300" b="1">
                 <a:solidFill>
                   <a:srgbClr val="202428"/>
@@ -5237,6 +5819,7 @@
           <a:lstStyle xmlns:a="http://schemas.openxmlformats.org/drawingml/2006/main"/>
           <a:p xmlns:a="http://schemas.openxmlformats.org/drawingml/2006/main">
             <a:pPr>
+              <a:buNone/>
               <a:defRPr sz="1425" b="0">
                 <a:solidFill>
                   <a:srgbClr val="535C62"/>
@@ -5276,8 +5859,8 @@
         </p:nvSpPr>
         <p:spPr>
           <a:xfrm xmlns:a="http://schemas.openxmlformats.org/drawingml/2006/main">
-            <a:off x="609600" y="1619250"/>
-            <a:ext cx="10972800" cy="952500"/>
+            <a:off x="609600" y="1609725"/>
+            <a:ext cx="10972800" cy="1066800"/>
           </a:xfrm>
           <a:prstGeom xmlns:a="http://schemas.openxmlformats.org/drawingml/2006/main" prst="rect">
             <a:avLst/>
@@ -5294,7 +5877,8 @@
           <a:lstStyle xmlns:a="http://schemas.openxmlformats.org/drawingml/2006/main"/>
           <a:p xmlns:a="http://schemas.openxmlformats.org/drawingml/2006/main">
             <a:pPr>
-              <a:defRPr sz="2400" b="1">
+              <a:buNone/>
+              <a:defRPr sz="2625" b="1">
                 <a:solidFill>
                   <a:srgbClr val="137968"/>
                 </a:solidFill>
@@ -5304,7 +5888,7 @@
               </a:defRPr>
             </a:pPr>
             <a:r>
-              <a:rPr sz="2400" b="1">
+              <a:rPr sz="2625" b="1">
                 <a:solidFill>
                   <a:srgbClr val="137968"/>
                 </a:solidFill>
@@ -5312,7 +5896,31 @@
                 <a:ea typeface="Arial"/>
                 <a:cs typeface="Arial"/>
               </a:rPr>
-              <a:t>A memória ajudou a orientar a exploração e antecipar a limpeza.</a:t>
+              <a:t>A memória favoreceu a exploração</a:t>
+            </a:r>
+          </a:p>
+          <a:p xmlns:a="http://schemas.openxmlformats.org/drawingml/2006/main">
+            <a:pPr>
+              <a:buNone/>
+              <a:defRPr sz="2625" b="1">
+                <a:solidFill>
+                  <a:srgbClr val="137968"/>
+                </a:solidFill>
+                <a:latin typeface="Arial"/>
+                <a:ea typeface="Arial"/>
+                <a:cs typeface="Arial"/>
+              </a:defRPr>
+            </a:pPr>
+            <a:r>
+              <a:rPr sz="2625" b="1">
+                <a:solidFill>
+                  <a:srgbClr val="137968"/>
+                </a:solidFill>
+                <a:latin typeface="Arial"/>
+                <a:ea typeface="Arial"/>
+                <a:cs typeface="Arial"/>
+              </a:rPr>
+              <a:t>e antecipou a limpeza nos testes.</a:t>
             </a:r>
           </a:p>
         </p:txBody>
@@ -5351,9 +5959,10 @@
           <a:lstStyle xmlns:a="http://schemas.openxmlformats.org/drawingml/2006/main"/>
           <a:p xmlns:a="http://schemas.openxmlformats.org/drawingml/2006/main">
             <a:pPr>
+              <a:buNone/>
               <a:defRPr sz="2175" b="1">
                 <a:solidFill>
-                  <a:srgbClr val="202428"/>
+                  <a:srgbClr val="426BA5"/>
                 </a:solidFill>
                 <a:latin typeface="Arial"/>
                 <a:ea typeface="Arial"/>
@@ -5363,7 +5972,7 @@
             <a:r>
               <a:rPr sz="2175" b="1">
                 <a:solidFill>
-                  <a:srgbClr val="202428"/>
+                  <a:srgbClr val="426BA5"/>
                 </a:solidFill>
                 <a:latin typeface="Arial"/>
                 <a:ea typeface="Arial"/>
@@ -5408,6 +6017,7 @@
           <a:lstStyle xmlns:a="http://schemas.openxmlformats.org/drawingml/2006/main"/>
           <a:p xmlns:a="http://schemas.openxmlformats.org/drawingml/2006/main">
             <a:pPr>
+              <a:buNone/>
               <a:defRPr sz="2100" b="0">
                 <a:solidFill>
                   <a:srgbClr val="202428"/>
@@ -5431,6 +6041,7 @@
           </a:p>
           <a:p xmlns:a="http://schemas.openxmlformats.org/drawingml/2006/main">
             <a:pPr>
+              <a:buNone/>
               <a:defRPr sz="2100" b="0">
                 <a:solidFill>
                   <a:srgbClr val="202428"/>
@@ -5488,9 +6099,10 @@
           <a:lstStyle xmlns:a="http://schemas.openxmlformats.org/drawingml/2006/main"/>
           <a:p xmlns:a="http://schemas.openxmlformats.org/drawingml/2006/main">
             <a:pPr>
+              <a:buNone/>
               <a:defRPr sz="2175" b="1">
                 <a:solidFill>
-                  <a:srgbClr val="202428"/>
+                  <a:srgbClr val="426BA5"/>
                 </a:solidFill>
                 <a:latin typeface="Arial"/>
                 <a:ea typeface="Arial"/>
@@ -5500,7 +6112,7 @@
             <a:r>
               <a:rPr sz="2175" b="1">
                 <a:solidFill>
-                  <a:srgbClr val="202428"/>
+                  <a:srgbClr val="426BA5"/>
                 </a:solidFill>
                 <a:latin typeface="Arial"/>
                 <a:ea typeface="Arial"/>
@@ -5545,6 +6157,7 @@
           <a:lstStyle xmlns:a="http://schemas.openxmlformats.org/drawingml/2006/main"/>
           <a:p xmlns:a="http://schemas.openxmlformats.org/drawingml/2006/main">
             <a:pPr>
+              <a:buNone/>
               <a:defRPr sz="2100" b="0">
                 <a:solidFill>
                   <a:srgbClr val="202428"/>
@@ -5568,6 +6181,7 @@
           </a:p>
           <a:p xmlns:a="http://schemas.openxmlformats.org/drawingml/2006/main">
             <a:pPr>
+              <a:buNone/>
               <a:defRPr sz="2100" b="0">
                 <a:solidFill>
                   <a:srgbClr val="202428"/>
@@ -5590,6 +6204,36 @@
             </a:r>
           </a:p>
         </p:txBody>
+      </p:sp>
+      <p:sp>
+        <p:nvSpPr>
+          <p:cNvPr id="9" name="">
+            <a:extLst xmlns:a="http://schemas.openxmlformats.org/drawingml/2006/main">
+              <a:ext uri="{FF2B5EF4-FFF2-40B4-BE49-F238E27FC236}">
+                <a16:creationId xmlns:a16="http://schemas.microsoft.com/office/drawing/2014/main" id="{EDE3B2ED-81C0-429A-BA4B-71E573901423}"/>
+              </a:ext>
+            </a:extLst>
+          </p:cNvPr>
+          <p:cNvSpPr>
+            <a:spLocks xmlns:a="http://schemas.openxmlformats.org/drawingml/2006/main" noGrp="1"/>
+          </p:cNvSpPr>
+          <p:nvPr/>
+        </p:nvSpPr>
+        <p:spPr>
+          <a:xfrm xmlns:a="http://schemas.openxmlformats.org/drawingml/2006/main">
+            <a:off x="685800" y="1276350"/>
+            <a:ext cx="10820400" cy="0"/>
+          </a:xfrm>
+          <a:prstGeom xmlns:a="http://schemas.openxmlformats.org/drawingml/2006/main" prst="line">
+            <a:avLst/>
+          </a:prstGeom>
+          <a:noFill xmlns:a="http://schemas.openxmlformats.org/drawingml/2006/main"/>
+          <a:ln xmlns:a="http://schemas.openxmlformats.org/drawingml/2006/main" w="9525">
+            <a:solidFill>
+              <a:srgbClr val="DDE5E8"/>
+            </a:solidFill>
+          </a:ln>
+        </p:spPr>
       </p:sp>
     </p:spTree>
     <p:extLst>

</xml_diff>

<commit_message>
Corrige configuracoes pequenas e atualiza os seis slides
</commit_message>
<xml_diff>
--- a/apresentacao_agentes.pptx
+++ b/apresentacao_agentes.pptx
@@ -2,18 +2,18 @@
 <file path=ppt/presentation.xml><?xml version="1.0" encoding="utf-8"?>
 <p:presentation xmlns:p="http://schemas.openxmlformats.org/presentationml/2006/main">
   <p:sldMasterIdLst>
-    <p:sldMasterId xmlns:r="http://schemas.openxmlformats.org/officeDocument/2006/relationships" id="2147483648" r:id="R527a09dabb0c4e45"/>
+    <p:sldMasterId xmlns:r="http://schemas.openxmlformats.org/officeDocument/2006/relationships" id="2147483648" r:id="Rd06211aeb0254c22"/>
   </p:sldMasterIdLst>
   <p:notesMasterIdLst>
-    <p:notesMasterId xmlns:r="http://schemas.openxmlformats.org/officeDocument/2006/relationships" r:id="R35ef1386e48d453d"/>
+    <p:notesMasterId xmlns:r="http://schemas.openxmlformats.org/officeDocument/2006/relationships" r:id="R8171582a7dc64920"/>
   </p:notesMasterIdLst>
   <p:sldIdLst>
-    <p:sldId xmlns:r="http://schemas.openxmlformats.org/officeDocument/2006/relationships" id="256" r:id="R835389b5c3d9454c"/>
-    <p:sldId xmlns:r="http://schemas.openxmlformats.org/officeDocument/2006/relationships" id="257" r:id="R22e9d9c80f1441a0"/>
-    <p:sldId xmlns:r="http://schemas.openxmlformats.org/officeDocument/2006/relationships" id="258" r:id="R112c046797b04fa7"/>
-    <p:sldId xmlns:r="http://schemas.openxmlformats.org/officeDocument/2006/relationships" id="259" r:id="R2a00ccaaef924759"/>
-    <p:sldId xmlns:r="http://schemas.openxmlformats.org/officeDocument/2006/relationships" id="260" r:id="R3fb428268f9b4a58"/>
-    <p:sldId xmlns:r="http://schemas.openxmlformats.org/officeDocument/2006/relationships" id="261" r:id="Ra97fe488d5584cab"/>
+    <p:sldId xmlns:r="http://schemas.openxmlformats.org/officeDocument/2006/relationships" id="256" r:id="R0f2253127204444c"/>
+    <p:sldId xmlns:r="http://schemas.openxmlformats.org/officeDocument/2006/relationships" id="257" r:id="R6455e61e5d674356"/>
+    <p:sldId xmlns:r="http://schemas.openxmlformats.org/officeDocument/2006/relationships" id="258" r:id="Re05790c9b356491d"/>
+    <p:sldId xmlns:r="http://schemas.openxmlformats.org/officeDocument/2006/relationships" id="259" r:id="R6e7c0a350db24366"/>
+    <p:sldId xmlns:r="http://schemas.openxmlformats.org/officeDocument/2006/relationships" id="260" r:id="R7af0d3a64a234eec"/>
+    <p:sldId xmlns:r="http://schemas.openxmlformats.org/officeDocument/2006/relationships" id="261" r:id="Raa208cffd0a44717"/>
   </p:sldIdLst>
   <p:sldSz cx="12192000" cy="6858000"/>
   <p:notesSz cx="6858000" cy="9144000"/>
@@ -457,7 +457,7 @@
           </a:p>
           <a:p xmlns:a="http://schemas.openxmlformats.org/drawingml/2006/main">
             <a:r>
-              <a:t>O objetivo foi comparar dois aspiradores: um reativo simples e outro reativo baseado em modelos, que chamamos de agente com memória. Criamos um ambiente 4 por 4, com quatro quadrados inicialmente sujos em cada cenário. O primeiro cenário não tem obstáculos, e os outros dois têm dois obstáculos cada. Também mudamos a posição inicial e a distribuição da sujeira. Cada agente roda separadamente por 80 períodos, nas mesmas condições iniciais. O mundo é determinístico: uma ação nas mesmas condições tem sempre o mesmo efeito. A escolha aleatória do agente simples não altera essa propriedade. A observação é parcial: os agentes detectam apenas a sujeira onde estão e as passagens vizinhas. Eles não recebem o mapa nem suas dimensões. Não surge sujeira nova.</a:t>
+              <a:t>O objetivo foi comparar dois aspiradores: um reativo simples e outro reativo baseado em modelo. O ambiente é uma grade 4 por 4, determinística e parcialmente observável. Os agentes percebem a sujeira da célula atual e as passagens vizinhas. Não recebem o mapa, o tamanho, os obstáculos nem a sujeira distante. Não surge sujeira nova. Há três mapas fixos e trinta mapas aleatórios, com a mesma condição inicial para os dois programas.</a:t>
             </a:r>
           </a:p>
           <a:p xmlns:a="http://schemas.openxmlformats.org/drawingml/2006/main">
@@ -467,7 +467,7 @@
           </a:p>
           <a:p xmlns:a="http://schemas.openxmlformats.org/drawingml/2006/main">
             <a:r>
-              <a:t>Fontes: Projeto 1 - Avaliação Experimental de Agentes Inteligentes.pdf, páginas 1 e 2. Implementação e resultados: agentes.py, três cenários, 80 períodos, semente 42.</a:t>
+              <a:t>Fontes: enunciado do Projeto 1 e agentes.py. Valores padrão: grade 4×4, 80 períodos, 3 cenários fixos, 30 aleatórios e 5 sementes do agente simples.</a:t>
             </a:r>
           </a:p>
         </p:txBody>
@@ -537,7 +537,7 @@
           <a:lstStyle xmlns:a="http://schemas.openxmlformats.org/drawingml/2006/main"/>
           <a:p xmlns:a="http://schemas.openxmlformats.org/drawingml/2006/main">
             <a:r>
-              <a:t>Tempo sugerido: 1 minuto e 30 segundos</a:t>
+              <a:t>Tempo sugerido: 1 minuto e 40 segundos</a:t>
             </a:r>
           </a:p>
           <a:p xmlns:a="http://schemas.openxmlformats.org/drawingml/2006/main">
@@ -547,7 +547,7 @@
           </a:p>
           <a:p xmlns:a="http://schemas.openxmlformats.org/drawingml/2006/main">
             <a:r>
-              <a:t>Os dois agentes usam regras condição-ação. A primeira regra é igual: se o quadrado atual está sujo, aspirar. Se estiver limpo, o agente simples sorteia uma passagem livre. Ele não registra os lugares que visitou. A semente 42 permite repetir as escolhas e os resultados. O outro agente mantém uma posição relativa ao ponto de partida e um dicionário com o número de visitas a cada posição. O início recebe uma visita e posições desconhecidas valem zero. Quando se move, ele atualiza sua posição e aumenta a contagem do destino. Entre as passagens livres, escolhe o destino menos visitado. Em empate, segue a ordem direita, baixo, esquerda e cima. Como o sensor informa passagem livre e o ambiente é determinístico, essa atualização corresponde ao movimento real. Sem passagem livre, os agentes ficam parados naquele período.</a:t>
+              <a:t>Os dois usam regras condição-ação. A primeira é igual: se o quadrado atual está sujo, aspirar.</a:t>
             </a:r>
           </a:p>
           <a:p xmlns:a="http://schemas.openxmlformats.org/drawingml/2006/main">
@@ -557,7 +557,37 @@
           </a:p>
           <a:p xmlns:a="http://schemas.openxmlformats.org/drawingml/2006/main">
             <a:r>
-              <a:t>Fontes: Projeto 1 - Avaliação Experimental de Agentes Inteligentes.pdf, páginas 1 e 2. Implementação e resultados: agentes.py, três cenários, 80 períodos, semente 42.</a:t>
+              <a:t>O agente simples, se está limpo, sorteia uma passagem livre. Não registra o que já viu. A semente 42 repete as escolhas.</a:t>
+            </a:r>
+          </a:p>
+          <a:p xmlns:a="http://schemas.openxmlformats.org/drawingml/2006/main">
+            <a:r>
+              <a:t/>
+            </a:r>
+          </a:p>
+          <a:p xmlns:a="http://schemas.openxmlformats.org/drawingml/2006/main">
+            <a:r>
+              <a:t>O agente com memória guarda um estado interno em coordenadas relativas ao ponto de partida: células limpas, bloqueadas ou ainda não visitadas, e o número de visitas. A cada período ele faz três coisas. Primeiro, atualiza o estado com o percepto local. Depois, aplica a regra: se há sujeira conhecida ou célula não visitada, dá um passo em direção à mais próxima; se não há, para. No empate, prefere o vizinho menos visitado e, depois, a ordem direita, baixo, esquerda e cima. Por último, aplica a ação no próprio modelo, porque o sensor já informou que a passagem está livre e o efeito no mundo é determinístico.</a:t>
+            </a:r>
+          </a:p>
+          <a:p xmlns:a="http://schemas.openxmlformats.org/drawingml/2006/main">
+            <a:r>
+              <a:t/>
+            </a:r>
+          </a:p>
+          <a:p xmlns:a="http://schemas.openxmlformats.org/drawingml/2006/main">
+            <a:r>
+              <a:t>A sujeira distante não entra no mapa. O sensor só acusa sujeira debaixo do agente, e a regra aspira nessa mesma hora.</a:t>
+            </a:r>
+          </a:p>
+          <a:p xmlns:a="http://schemas.openxmlformats.org/drawingml/2006/main">
+            <a:r>
+              <a:t/>
+            </a:r>
+          </a:p>
+          <a:p xmlns:a="http://schemas.openxmlformats.org/drawingml/2006/main">
+            <a:r>
+              <a:t>Fontes: enunciado do Projeto 1 e agentes.py. Valores padrão: grade 4×4, 80 períodos, 3 cenários fixos, 30 aleatórios e 5 sementes do agente simples.</a:t>
             </a:r>
           </a:p>
         </p:txBody>
@@ -637,7 +667,7 @@
           </a:p>
           <a:p xmlns:a="http://schemas.openxmlformats.org/drawingml/2006/main">
             <a:r>
-              <a:t>Cada ação ocupa um período, incluindo aspirar. Calculamos a primeira medida somando o número de quadrados limpos ao fim de cada um dos 80 períodos. Os quadrados que já estavam limpos também contam, e os obstáculos ficam fora da conta. Se houver seis quadrados limpos em um período, ganhamos seis pontos naquele período. Se continuarem limpos no próximo, ganhamos mais seis. Por isso, limpar cedo é vantajoso. Para a segunda medida, adotamos a primeira pontuação menos o número de movimentos realizados. O enunciado não repete a expressão em cada período ao descrever a segunda medida, então essa é uma interpretação explicitamente assumida. Aspirar ocupa tempo, mas não sofre o desconto de movimento. O simulador conhece todo o ambiente para pontuar, mas os agentes só recebem informações locais.</a:t>
+              <a:t>Cada ação ocupa um período, inclusive aspirar. A primeira medida soma os quadrados limpos ao fim de cada um dos 80 períodos. Quadrados que já estavam limpos também contam. Obstáculos ficam de fora. Limpar cedo aumenta essa soma. A segunda medida é a primeira menos o número de movimentos. Aspirar gasta tempo, mas não entra nesse desconto. O simulador conhece o ambiente inteiro para pontuar. Os agentes recebem só a informação local.</a:t>
             </a:r>
           </a:p>
           <a:p xmlns:a="http://schemas.openxmlformats.org/drawingml/2006/main">
@@ -647,7 +677,7 @@
           </a:p>
           <a:p xmlns:a="http://schemas.openxmlformats.org/drawingml/2006/main">
             <a:r>
-              <a:t>Fontes: Projeto 1 - Avaliação Experimental de Agentes Inteligentes.pdf, páginas 1 e 2. Implementação e resultados: agentes.py, três cenários, 80 períodos, semente 42.</a:t>
+              <a:t>Fontes: enunciado do Projeto 1 e agentes.py. Valores padrão: grade 4×4, 80 períodos, 3 cenários fixos, 30 aleatórios e 5 sementes do agente simples.</a:t>
             </a:r>
           </a:p>
         </p:txBody>
@@ -727,17 +757,32 @@
           </a:p>
           <a:p xmlns:a="http://schemas.openxmlformats.org/drawingml/2006/main">
             <a:r>
-              <a:t>Esta tabela mostra as seis execuções, com um teste por agente em cada cenário. O agente com memória terminou sem sujeira em todos os casos. O simples deixou um quadrado sujo no cenário dois. Quando um agente limpa os quatro quadrados, gasta quatro ações aspirando e 76 se movendo. No cenário dois, o simples aspira três vezes e se move 77 vezes. As pontuações mostram também quando ele limpou: nos cenários um e três, ambos terminaram sem sujeira e fizeram o mesmo número de movimentos, mas o agente com memória obteve mais pontos por limpar mais cedo no conjunto da execução. As médias abaixo usam os três cenários com o mesmo peso. Comparamos os agentes dentro de cada cenário, pois a presença de obstáculos altera a quantidade de quadrados que podem pontuar.</a:t>
-            </a:r>
-          </a:p>
-          <a:p xmlns:a="http://schemas.openxmlformats.org/drawingml/2006/main">
-            <a:r>
               <a:t/>
             </a:r>
           </a:p>
           <a:p xmlns:a="http://schemas.openxmlformats.org/drawingml/2006/main">
             <a:r>
-              <a:t>Fontes: Projeto 1 - Avaliação Experimental de Agentes Inteligentes.pdf, páginas 1 e 2. Implementação e resultados: agentes.py, três cenários, 80 períodos, semente 42.</a:t>
+              <a:t>Médias: simples, 1064,00 e 987,67; com memória, 1136,67 e 1121,00.</a:t>
+            </a:r>
+          </a:p>
+          <a:p xmlns:a="http://schemas.openxmlformats.org/drawingml/2006/main">
+            <a:r>
+              <a:t/>
+            </a:r>
+          </a:p>
+          <a:p xmlns:a="http://schemas.openxmlformats.org/drawingml/2006/main">
+            <a:r>
+              <a:t>Alc. é a sujeira que ainda dava para alcançar. No cenário 2 o agente simples termina com um quadrado sujo alcançável. O agente com memória limpa os quatro nos três mapas e para entre os períodos 18 e 24. A primeira pontuação sobe porque a limpeza acontece mais cedo. A segunda sobe também porque, depois disso, ele não continua se movendo.</a:t>
+            </a:r>
+          </a:p>
+          <a:p xmlns:a="http://schemas.openxmlformats.org/drawingml/2006/main">
+            <a:r>
+              <a:t/>
+            </a:r>
+          </a:p>
+          <a:p xmlns:a="http://schemas.openxmlformats.org/drawingml/2006/main">
+            <a:r>
+              <a:t>Fontes: enunciado do Projeto 1 e agentes.py. Valores padrão: grade 4×4, 80 períodos, 3 cenários fixos, 30 aleatórios e 5 sementes do agente simples.</a:t>
             </a:r>
           </a:p>
         </p:txBody>
@@ -807,7 +852,7 @@
           <a:lstStyle xmlns:a="http://schemas.openxmlformats.org/drawingml/2006/main"/>
           <a:p xmlns:a="http://schemas.openxmlformats.org/drawingml/2006/main">
             <a:r>
-              <a:t>Tempo sugerido: 1 minuto</a:t>
+              <a:t>Tempo sugerido: 1 minuto e 20 segundos</a:t>
             </a:r>
           </a:p>
           <a:p xmlns:a="http://schemas.openxmlformats.org/drawingml/2006/main">
@@ -817,7 +862,7 @@
           </a:p>
           <a:p xmlns:a="http://schemas.openxmlformats.org/drawingml/2006/main">
             <a:r>
-              <a:t>Os gráficos mostram as mesmas pontuações da tabela. Azul representa o agente simples e verde representa o agente com memória. Cada grupo reúne os dois agentes no mesmo cenário. O gráfico da esquerda mostra a limpeza acumulada e o da direita desconta os movimentos. Ambos começam em zero e usam a mesma escala. O agente com memória ficou à frente nos três cenários, nas duas medidas. A diferença média foi de aproximadamente 70,67 pontos na primeira medida e 71 pontos na segunda. A penalização quase não altera a comparação, porque o número de movimentos é praticamente igual. Estes resultados se referem a três configurações fixas e a uma única semente do agente simples, sem estimar a variabilidade de outras escolhas aleatórias.</a:t>
+              <a:t>Os dois gráficos do slide mostram os três cenários fixos, e o texto abaixo destaca a média de Pontos 2 nos trinta mapas aleatórios. Azul é o agente simples e verde é o agente com memória. O arquivo `resultados.svg` traz também o gráfico das médias aleatórias, com o desvio entre configurações.</a:t>
             </a:r>
           </a:p>
           <a:p xmlns:a="http://schemas.openxmlformats.org/drawingml/2006/main">
@@ -827,7 +872,27 @@
           </a:p>
           <a:p xmlns:a="http://schemas.openxmlformats.org/drawingml/2006/main">
             <a:r>
-              <a:t>Fontes: Projeto 1 - Avaliação Experimental de Agentes Inteligentes.pdf, páginas 1 e 2. Implementação e resultados: agentes.py, três cenários, 80 períodos, semente 42.</a:t>
+              <a:t>Nesses trinta mapas, a média de Pontos 1 foi 1108,29 para o simples e 1162,20 para o com memória. A média de Pontos 2 foi 1031,60 e 1146,80. O desvio entre cenários ficou em torno de 77 pontos para o simples e 64 para o com memória. O agente com memória teve Pontos 2 maior nos 30 casos. Ele removeu a sujeira alcançável em todos. O simples fez isso em 127 das 150 execuções, contando cinco sementes por mapa.</a:t>
+            </a:r>
+          </a:p>
+          <a:p xmlns:a="http://schemas.openxmlformats.org/drawingml/2006/main">
+            <a:r>
+              <a:t/>
+            </a:r>
+          </a:p>
+          <a:p xmlns:a="http://schemas.openxmlformats.org/drawingml/2006/main">
+            <a:r>
+              <a:t>A animação do cenário 2 mostra o comportamento por trás da tabela: o simples volta a células já limpas e deixa uma suja; o com memória cobre a fronteira do mapa e, no período 18, a ação passa a ser parar. O contador de movimentos dele trava em 13. O do simples segue até 77.</a:t>
+            </a:r>
+          </a:p>
+          <a:p xmlns:a="http://schemas.openxmlformats.org/drawingml/2006/main">
+            <a:r>
+              <a:t/>
+            </a:r>
+          </a:p>
+          <a:p xmlns:a="http://schemas.openxmlformats.org/drawingml/2006/main">
+            <a:r>
+              <a:t>Fontes: enunciado do Projeto 1 e agentes.py. Valores padrão: grade 4×4, 80 períodos, 3 cenários fixos, 30 aleatórios e 5 sementes do agente simples.</a:t>
             </a:r>
           </a:p>
         </p:txBody>
@@ -907,7 +972,7 @@
           </a:p>
           <a:p xmlns:a="http://schemas.openxmlformats.org/drawingml/2006/main">
             <a:r>
-              <a:t>Racionalidade significa escolher ações adequadas à medida de desempenho, considerando a informação disponível. A memória permitiu usar o histórico para orientar a exploração e favoreceu a limpeza mais cedo nestes testes. Isso explica as maiores pontuações. Entretanto, o agente não é necessariamente ótimo. Os dois continuam andando até completar 80 períodos e não reconhecem que toda a região acessível está limpa. Depois da limpeza completa, esses movimentos deixam de ajudar e reduzem a segunda pontuação. O simulador sabe que acabou a sujeira, mas essa informação global não é entregue aos agentes. A conclusão é que o agente com memória teve melhor desempenho nos testes realizados, e não que sempre será melhor. Para ampliar a evidência, podemos repetir com outras sementes e configurações. Uma melhoria futura seria construir um mapa dos locais descobertos e reconhecer o término da exploração antes de decidir parar.</a:t>
+              <a:t>Racionalidade é escolher a ação adequada à medida de desempenho, com a informação disponível. O mapa interno permite explorar sem repetir à toa e reconhecer quando a região conhecida está limpa. Parar nesse momento é adequado à segunda medida: cada movimento depois da limpeza desconta um ponto e não aumenta a limpeza. O agente simples não tem como saber disso, porque esquece o que já percebeu.</a:t>
             </a:r>
           </a:p>
           <a:p xmlns:a="http://schemas.openxmlformats.org/drawingml/2006/main">
@@ -917,7 +982,17 @@
           </a:p>
           <a:p xmlns:a="http://schemas.openxmlformats.org/drawingml/2006/main">
             <a:r>
-              <a:t>Fontes: Projeto 1 - Avaliação Experimental de Agentes Inteligentes.pdf, páginas 1 e 2. Implementação e resultados: agentes.py, três cenários, 80 períodos, semente 42.</a:t>
+              <a:t>Isso não torna o programa ótimo em qualquer mundo. A grade tem tamanho fixo, os trinta mapas usam até dois obstáculos e o sorteio do agente simples está limitado a cinco sementes. A conclusão é que, nestes testes, o agente com memória foi mais adequado às duas medidas, em especial à que penaliza movimento.</a:t>
+            </a:r>
+          </a:p>
+          <a:p xmlns:a="http://schemas.openxmlformats.org/drawingml/2006/main">
+            <a:r>
+              <a:t/>
+            </a:r>
+          </a:p>
+          <a:p xmlns:a="http://schemas.openxmlformats.org/drawingml/2006/main">
+            <a:r>
+              <a:t>Fontes: enunciado do Projeto 1 e agentes.py. Valores padrão: grade 4×4, 80 períodos, 3 cenários fixos, 30 aleatórios e 5 sementes do agente simples.</a:t>
             </a:r>
           </a:p>
         </p:txBody>
@@ -985,7 +1060,7 @@
   </p:cSld>
   <p:clrMap bg1="lt1" tx1="dk1" bg2="lt2" tx2="dk2" accent1="accent1" accent2="accent2" accent3="accent3" accent4="accent4" accent5="accent5" accent6="accent6" hlink="hlink" folHlink="folHlink"/>
   <p:sldLayoutIdLst>
-    <p:sldLayoutId xmlns:r="http://schemas.openxmlformats.org/officeDocument/2006/relationships" id="2147483649" r:id="Rc871dba73d3b465c"/>
+    <p:sldLayoutId xmlns:r="http://schemas.openxmlformats.org/officeDocument/2006/relationships" id="2147483649" r:id="R02fe2c13fb894d79"/>
   </p:sldLayoutIdLst>
   <p:txStyles>
     <p:titleStyle>
@@ -1513,15 +1588,15 @@
 </file>
 
 <file path=ppt/slides/charts/chart1.xml><?xml version="1.0" encoding="utf-8"?>
-<c:chartSpace xmlns:c="http://schemas.openxmlformats.org/drawingml/2006/chart" xmlns:r="http://schemas.openxmlformats.org/officeDocument/2006/relationships">
+<c:chartSpace xmlns:a="http://schemas.openxmlformats.org/drawingml/2006/main" xmlns:c="http://schemas.openxmlformats.org/drawingml/2006/chart" xmlns:r="http://schemas.openxmlformats.org/officeDocument/2006/relationships">
   <c:lang val="en-US"/>
   <c:chart>
     <c:title>
       <c:tx>
         <c:rich>
-          <a:bodyPr xmlns:a="http://schemas.openxmlformats.org/drawingml/2006/main"/>
-          <a:lstStyle xmlns:a="http://schemas.openxmlformats.org/drawingml/2006/main"/>
-          <a:p xmlns:a="http://schemas.openxmlformats.org/drawingml/2006/main">
+          <a:bodyPr/>
+          <a:lstStyle/>
+          <a:p>
             <a:r>
               <a:rPr sz="2175" b="1">
                 <a:solidFill>
@@ -1538,9 +1613,9 @@
       </c:tx>
       <c:overlay val="0"/>
       <c:txPr>
-        <a:bodyPr xmlns:a="http://schemas.openxmlformats.org/drawingml/2006/main" anchorCtr="1"/>
-        <a:lstStyle xmlns:a="http://schemas.openxmlformats.org/drawingml/2006/main"/>
-        <a:p xmlns:a="http://schemas.openxmlformats.org/drawingml/2006/main">
+        <a:bodyPr anchorCtr="1"/>
+        <a:lstStyle/>
+        <a:p>
           <a:pPr>
             <a:defRPr sz="2175" b="1">
               <a:solidFill>
@@ -1566,7 +1641,7 @@
             <c:v>Simples</c:v>
           </c:tx>
           <c:spPr>
-            <a:solidFill xmlns:a="http://schemas.openxmlformats.org/drawingml/2006/main">
+            <a:solidFill>
               <a:srgbClr val="426BA5"/>
             </a:solidFill>
           </c:spPr>
@@ -1613,7 +1688,7 @@
             <c:v>Com memória</c:v>
           </c:tx>
           <c:spPr>
-            <a:solidFill xmlns:a="http://schemas.openxmlformats.org/drawingml/2006/main">
+            <a:solidFill>
               <a:srgbClr val="137968"/>
             </a:solidFill>
           </c:spPr>
@@ -1647,7 +1722,7 @@
                   <c:v>1083</c:v>
                 </c:pt>
                 <c:pt idx="2">
-                  <c:v>1065</c:v>
+                  <c:v>1071</c:v>
                 </c:pt>
               </c:numCache>
             </c:numRef>
@@ -1655,9 +1730,9 @@
         </c:ser>
         <c:dLbls>
           <c:txPr>
-            <a:bodyPr xmlns:a="http://schemas.openxmlformats.org/drawingml/2006/main" anchorCtr="1"/>
-            <a:lstStyle xmlns:a="http://schemas.openxmlformats.org/drawingml/2006/main"/>
-            <a:p xmlns:a="http://schemas.openxmlformats.org/drawingml/2006/main">
+            <a:bodyPr anchorCtr="1"/>
+            <a:lstStyle/>
+            <a:p>
               <a:pPr>
                 <a:defRPr sz="1425">
                   <a:solidFill>
@@ -1694,7 +1769,7 @@
         <c:majorTickMark val="none"/>
         <c:minorTickMark val="none"/>
         <c:spPr>
-          <a:ln xmlns:a="http://schemas.openxmlformats.org/drawingml/2006/main" w="9525">
+          <a:ln w="9525">
             <a:solidFill>
               <a:srgbClr val="D4D4D4"/>
             </a:solidFill>
@@ -1702,9 +1777,9 @@
           </a:ln>
         </c:spPr>
         <c:txPr>
-          <a:bodyPr xmlns:a="http://schemas.openxmlformats.org/drawingml/2006/main" anchorCtr="1"/>
-          <a:lstStyle xmlns:a="http://schemas.openxmlformats.org/drawingml/2006/main"/>
-          <a:p xmlns:a="http://schemas.openxmlformats.org/drawingml/2006/main">
+          <a:bodyPr anchorCtr="1"/>
+          <a:lstStyle/>
+          <a:p>
             <a:pPr>
               <a:defRPr sz="1575">
                 <a:solidFill>
@@ -1730,7 +1805,7 @@
         <c:axPos val="l"/>
         <c:majorGridlines>
           <c:spPr>
-            <a:ln xmlns:a="http://schemas.openxmlformats.org/drawingml/2006/main" w="9525">
+            <a:ln w="9525">
               <a:solidFill>
                 <a:srgbClr val="E2E5E7"/>
               </a:solidFill>
@@ -1741,7 +1816,7 @@
         <c:majorTickMark val="none"/>
         <c:minorTickMark val="none"/>
         <c:spPr>
-          <a:ln xmlns:a="http://schemas.openxmlformats.org/drawingml/2006/main" w="9525">
+          <a:ln w="9525">
             <a:solidFill>
               <a:srgbClr val="D4D4D4"/>
             </a:solidFill>
@@ -1749,9 +1824,9 @@
           </a:ln>
         </c:spPr>
         <c:txPr>
-          <a:bodyPr xmlns:a="http://schemas.openxmlformats.org/drawingml/2006/main" anchorCtr="1"/>
-          <a:lstStyle xmlns:a="http://schemas.openxmlformats.org/drawingml/2006/main"/>
-          <a:p xmlns:a="http://schemas.openxmlformats.org/drawingml/2006/main">
+          <a:bodyPr anchorCtr="1"/>
+          <a:lstStyle/>
+          <a:p>
             <a:pPr>
               <a:defRPr sz="1425">
                 <a:solidFill>
@@ -1773,9 +1848,9 @@
       <c:legendPos val="b"/>
       <c:overlay val="0"/>
       <c:txPr>
-        <a:bodyPr xmlns:a="http://schemas.openxmlformats.org/drawingml/2006/main" anchorCtr="1"/>
-        <a:lstStyle xmlns:a="http://schemas.openxmlformats.org/drawingml/2006/main"/>
-        <a:p xmlns:a="http://schemas.openxmlformats.org/drawingml/2006/main">
+        <a:bodyPr anchorCtr="1"/>
+        <a:lstStyle/>
+        <a:p>
           <a:pPr>
             <a:defRPr sz="1575">
               <a:latin typeface="Arial"/>
@@ -1795,15 +1870,15 @@
 </file>
 
 <file path=ppt/slides/charts/chart2.xml><?xml version="1.0" encoding="utf-8"?>
-<c:chartSpace xmlns:c="http://schemas.openxmlformats.org/drawingml/2006/chart" xmlns:r="http://schemas.openxmlformats.org/officeDocument/2006/relationships">
+<c:chartSpace xmlns:a="http://schemas.openxmlformats.org/drawingml/2006/main" xmlns:c="http://schemas.openxmlformats.org/drawingml/2006/chart" xmlns:r="http://schemas.openxmlformats.org/officeDocument/2006/relationships">
   <c:lang val="en-US"/>
   <c:chart>
     <c:title>
       <c:tx>
         <c:rich>
-          <a:bodyPr xmlns:a="http://schemas.openxmlformats.org/drawingml/2006/main"/>
-          <a:lstStyle xmlns:a="http://schemas.openxmlformats.org/drawingml/2006/main"/>
-          <a:p xmlns:a="http://schemas.openxmlformats.org/drawingml/2006/main">
+          <a:bodyPr/>
+          <a:lstStyle/>
+          <a:p>
             <a:r>
               <a:rPr sz="2175" b="1">
                 <a:solidFill>
@@ -1820,9 +1895,9 @@
       </c:tx>
       <c:overlay val="0"/>
       <c:txPr>
-        <a:bodyPr xmlns:a="http://schemas.openxmlformats.org/drawingml/2006/main" anchorCtr="1"/>
-        <a:lstStyle xmlns:a="http://schemas.openxmlformats.org/drawingml/2006/main"/>
-        <a:p xmlns:a="http://schemas.openxmlformats.org/drawingml/2006/main">
+        <a:bodyPr anchorCtr="1"/>
+        <a:lstStyle/>
+        <a:p>
           <a:pPr>
             <a:defRPr sz="2175" b="1">
               <a:solidFill>
@@ -1848,7 +1923,7 @@
             <c:v>Simples</c:v>
           </c:tx>
           <c:spPr>
-            <a:solidFill xmlns:a="http://schemas.openxmlformats.org/drawingml/2006/main">
+            <a:solidFill>
               <a:srgbClr val="426BA5"/>
             </a:solidFill>
           </c:spPr>
@@ -1895,7 +1970,7 @@
             <c:v>Com memória</c:v>
           </c:tx>
           <c:spPr>
-            <a:solidFill xmlns:a="http://schemas.openxmlformats.org/drawingml/2006/main">
+            <a:solidFill>
               <a:srgbClr val="137968"/>
             </a:solidFill>
           </c:spPr>
@@ -1923,13 +1998,13 @@
                 <c:formatCode>0</c:formatCode>
                 <c:ptCount val="3"/>
                 <c:pt idx="0">
-                  <c:v>1180</c:v>
+                  <c:v>1241</c:v>
                 </c:pt>
                 <c:pt idx="1">
-                  <c:v>1007</c:v>
+                  <c:v>1070</c:v>
                 </c:pt>
                 <c:pt idx="2">
-                  <c:v>989</c:v>
+                  <c:v>1052</c:v>
                 </c:pt>
               </c:numCache>
             </c:numRef>
@@ -1937,9 +2012,9 @@
         </c:ser>
         <c:dLbls>
           <c:txPr>
-            <a:bodyPr xmlns:a="http://schemas.openxmlformats.org/drawingml/2006/main" anchorCtr="1"/>
-            <a:lstStyle xmlns:a="http://schemas.openxmlformats.org/drawingml/2006/main"/>
-            <a:p xmlns:a="http://schemas.openxmlformats.org/drawingml/2006/main">
+            <a:bodyPr anchorCtr="1"/>
+            <a:lstStyle/>
+            <a:p>
               <a:pPr>
                 <a:defRPr sz="1425">
                   <a:solidFill>
@@ -1976,7 +2051,7 @@
         <c:majorTickMark val="none"/>
         <c:minorTickMark val="none"/>
         <c:spPr>
-          <a:ln xmlns:a="http://schemas.openxmlformats.org/drawingml/2006/main" w="9525">
+          <a:ln w="9525">
             <a:solidFill>
               <a:srgbClr val="D4D4D4"/>
             </a:solidFill>
@@ -1984,9 +2059,9 @@
           </a:ln>
         </c:spPr>
         <c:txPr>
-          <a:bodyPr xmlns:a="http://schemas.openxmlformats.org/drawingml/2006/main" anchorCtr="1"/>
-          <a:lstStyle xmlns:a="http://schemas.openxmlformats.org/drawingml/2006/main"/>
-          <a:p xmlns:a="http://schemas.openxmlformats.org/drawingml/2006/main">
+          <a:bodyPr anchorCtr="1"/>
+          <a:lstStyle/>
+          <a:p>
             <a:pPr>
               <a:defRPr sz="1575">
                 <a:solidFill>
@@ -2012,7 +2087,7 @@
         <c:axPos val="l"/>
         <c:majorGridlines>
           <c:spPr>
-            <a:ln xmlns:a="http://schemas.openxmlformats.org/drawingml/2006/main" w="9525">
+            <a:ln w="9525">
               <a:solidFill>
                 <a:srgbClr val="E2E5E7"/>
               </a:solidFill>
@@ -2023,7 +2098,7 @@
         <c:majorTickMark val="none"/>
         <c:minorTickMark val="none"/>
         <c:spPr>
-          <a:ln xmlns:a="http://schemas.openxmlformats.org/drawingml/2006/main" w="9525">
+          <a:ln w="9525">
             <a:solidFill>
               <a:srgbClr val="D4D4D4"/>
             </a:solidFill>
@@ -2031,9 +2106,9 @@
           </a:ln>
         </c:spPr>
         <c:txPr>
-          <a:bodyPr xmlns:a="http://schemas.openxmlformats.org/drawingml/2006/main" anchorCtr="1"/>
-          <a:lstStyle xmlns:a="http://schemas.openxmlformats.org/drawingml/2006/main"/>
-          <a:p xmlns:a="http://schemas.openxmlformats.org/drawingml/2006/main">
+          <a:bodyPr anchorCtr="1"/>
+          <a:lstStyle/>
+          <a:p>
             <a:pPr>
               <a:defRPr sz="1425">
                 <a:solidFill>
@@ -2055,9 +2130,9 @@
       <c:legendPos val="b"/>
       <c:overlay val="0"/>
       <c:txPr>
-        <a:bodyPr xmlns:a="http://schemas.openxmlformats.org/drawingml/2006/main" anchorCtr="1"/>
-        <a:lstStyle xmlns:a="http://schemas.openxmlformats.org/drawingml/2006/main"/>
-        <a:p xmlns:a="http://schemas.openxmlformats.org/drawingml/2006/main">
+        <a:bodyPr anchorCtr="1"/>
+        <a:lstStyle/>
+        <a:p>
           <a:pPr>
             <a:defRPr sz="1575">
               <a:latin typeface="Arial"/>
@@ -2288,7 +2363,7 @@
                 <a:ea typeface="Arial"/>
                 <a:cs typeface="Arial"/>
               </a:rPr>
-              <a:t>Dois aspiradores em Python, sem interface gráfica</a:t>
+              <a:t>Dois aspiradores em Python, com visualização passo a passo</a:t>
             </a:r>
           </a:p>
         </p:txBody>
@@ -2525,6 +2600,7 @@
           <a:lstStyle xmlns:a="http://schemas.openxmlformats.org/drawingml/2006/main"/>
           <a:p xmlns:a="http://schemas.openxmlformats.org/drawingml/2006/main">
             <a:pPr>
+              <a:buNone/>
               <a:defRPr sz="1875" b="0">
                 <a:solidFill>
                   <a:srgbClr val="535C62"/>
@@ -2582,6 +2658,7 @@
           <a:lstStyle xmlns:a="http://schemas.openxmlformats.org/drawingml/2006/main"/>
           <a:p xmlns:a="http://schemas.openxmlformats.org/drawingml/2006/main">
             <a:pPr>
+              <a:buNone/>
               <a:defRPr sz="4650" b="1">
                 <a:solidFill>
                   <a:srgbClr val="137968"/>
@@ -2600,7 +2677,7 @@
                 <a:ea typeface="Arial"/>
                 <a:cs typeface="Arial"/>
               </a:rPr>
-              <a:t>3</a:t>
+              <a:t>3 + 30</a:t>
             </a:r>
           </a:p>
         </p:txBody>
@@ -2639,6 +2716,7 @@
           <a:lstStyle xmlns:a="http://schemas.openxmlformats.org/drawingml/2006/main"/>
           <a:p xmlns:a="http://schemas.openxmlformats.org/drawingml/2006/main">
             <a:pPr>
+              <a:buNone/>
               <a:defRPr sz="1875" b="0">
                 <a:solidFill>
                   <a:srgbClr val="535C62"/>
@@ -2657,7 +2735,7 @@
                 <a:ea typeface="Arial"/>
                 <a:cs typeface="Arial"/>
               </a:rPr>
-              <a:t>cenários iniciais</a:t>
+              <a:t>cenários fixos + aleatórios</a:t>
             </a:r>
           </a:p>
         </p:txBody>
@@ -2696,6 +2774,7 @@
           <a:lstStyle xmlns:a="http://schemas.openxmlformats.org/drawingml/2006/main"/>
           <a:p xmlns:a="http://schemas.openxmlformats.org/drawingml/2006/main">
             <a:pPr>
+              <a:buNone/>
               <a:defRPr sz="4650" b="1">
                 <a:solidFill>
                   <a:srgbClr val="426BA5"/>
@@ -2753,6 +2832,7 @@
           <a:lstStyle xmlns:a="http://schemas.openxmlformats.org/drawingml/2006/main"/>
           <a:p xmlns:a="http://schemas.openxmlformats.org/drawingml/2006/main">
             <a:pPr>
+              <a:buNone/>
               <a:defRPr sz="1875" b="0">
                 <a:solidFill>
                   <a:srgbClr val="535C62"/>
@@ -3268,7 +3348,7 @@
                 <a:ea typeface="Arial"/>
                 <a:cs typeface="Arial"/>
               </a:rPr>
-              <a:t>Limpo: prefere o vizinho menos visitado.</a:t>
+              <a:t>Explora pelo mapa conhecido.</a:t>
             </a:r>
           </a:p>
           <a:p xmlns:a="http://schemas.openxmlformats.org/drawingml/2006/main">
@@ -3292,7 +3372,7 @@
                 <a:ea typeface="Arial"/>
                 <a:cs typeface="Arial"/>
               </a:rPr>
-              <a:t>Guarda posição relativa e visitas.</a:t>
+              <a:t>Sem células a explorar: para.</a:t>
             </a:r>
           </a:p>
         </p:txBody>
@@ -3408,7 +3488,7 @@
                 <a:ea typeface="Arial"/>
                 <a:cs typeface="Arial"/>
               </a:rPr>
-              <a:t>Após mover, atualiza a posição e soma uma visita ao destino.</a:t>
+              <a:t>Registra células, visitas e posição a partir das percepções locais.</a:t>
             </a:r>
           </a:p>
           <a:p xmlns:a="http://schemas.openxmlformats.org/drawingml/2006/main">
@@ -3432,7 +3512,7 @@
                 <a:ea typeface="Arial"/>
                 <a:cs typeface="Arial"/>
               </a:rPr>
-              <a:t>Locais desconhecidos começam com zero visitas.</a:t>
+              <a:t>Busca em largura encontra a célula não visitada mais próxima.</a:t>
             </a:r>
           </a:p>
         </p:txBody>
@@ -4127,7 +4207,7 @@
       </p:sp>
       <p:graphicFrame>
         <p:nvGraphicFramePr>
-          <p:cNvPr id="13" name=""/>
+          <p:cNvPr id="14" name=""/>
           <p:cNvGraphicFramePr/>
           <p:nvPr/>
         </p:nvGraphicFramePr>
@@ -4526,7 +4606,7 @@
                           <a:ea typeface="Arial"/>
                           <a:cs typeface="Arial"/>
                         </a:rPr>
-                        <a:t>76</a:t>
+                        <a:t>15</a:t>
                       </a:r>
                     </a:p>
                   </a:txBody>
@@ -4574,7 +4654,7 @@
                           <a:ea typeface="Arial"/>
                           <a:cs typeface="Arial"/>
                         </a:rPr>
-                        <a:t>1180</a:t>
+                        <a:t>1241</a:t>
                       </a:r>
                     </a:p>
                   </a:txBody>
@@ -4818,7 +4898,7 @@
                           <a:ea typeface="Arial"/>
                           <a:cs typeface="Arial"/>
                         </a:rPr>
-                        <a:t>76</a:t>
+                        <a:t>13</a:t>
                       </a:r>
                     </a:p>
                   </a:txBody>
@@ -4866,7 +4946,7 @@
                           <a:ea typeface="Arial"/>
                           <a:cs typeface="Arial"/>
                         </a:rPr>
-                        <a:t>1007</a:t>
+                        <a:t>1070</a:t>
                       </a:r>
                     </a:p>
                   </a:txBody>
@@ -5110,7 +5190,7 @@
                           <a:ea typeface="Arial"/>
                           <a:cs typeface="Arial"/>
                         </a:rPr>
-                        <a:t>76</a:t>
+                        <a:t>19</a:t>
                       </a:r>
                     </a:p>
                   </a:txBody>
@@ -5134,7 +5214,7 @@
                           <a:ea typeface="Arial"/>
                           <a:cs typeface="Arial"/>
                         </a:rPr>
-                        <a:t>1065</a:t>
+                        <a:t>1071</a:t>
                       </a:r>
                     </a:p>
                   </a:txBody>
@@ -5158,7 +5238,7 @@
                           <a:ea typeface="Arial"/>
                           <a:cs typeface="Arial"/>
                         </a:rPr>
-                        <a:t>989</a:t>
+                        <a:t>1052</a:t>
                       </a:r>
                     </a:p>
                   </a:txBody>
@@ -5353,6 +5433,7 @@
           <a:lstStyle xmlns:a="http://schemas.openxmlformats.org/drawingml/2006/main"/>
           <a:p xmlns:a="http://schemas.openxmlformats.org/drawingml/2006/main">
             <a:pPr>
+              <a:buNone/>
               <a:defRPr sz="1950" b="1">
                 <a:solidFill>
                   <a:srgbClr val="137968"/>
@@ -5410,6 +5491,7 @@
           <a:lstStyle xmlns:a="http://schemas.openxmlformats.org/drawingml/2006/main"/>
           <a:p xmlns:a="http://schemas.openxmlformats.org/drawingml/2006/main">
             <a:pPr>
+              <a:buNone/>
               <a:defRPr sz="1800" b="0">
                 <a:solidFill>
                   <a:srgbClr val="202428"/>
@@ -5428,7 +5510,7 @@
                 <a:ea typeface="Arial"/>
                 <a:cs typeface="Arial"/>
               </a:rPr>
-              <a:t>Pontos 1: 1134,67     Pontos 2: 1058,67</a:t>
+              <a:t>Pontos 1: 1136,67     Pontos 2: 1121,00</a:t>
             </a:r>
           </a:p>
         </p:txBody>
@@ -5580,7 +5662,7 @@
       </p:sp>
       <p:graphicFrame>
         <p:nvGraphicFramePr>
-          <p:cNvPr id="12" name="Chart"/>
+          <p:cNvPr id="14" name="Chart"/>
           <p:cNvGraphicFramePr/>
           <p:nvPr/>
         </p:nvGraphicFramePr>
@@ -5590,13 +5672,13 @@
         </p:xfrm>
         <a:graphic xmlns:a="http://schemas.openxmlformats.org/drawingml/2006/main">
           <a:graphicData uri="http://schemas.openxmlformats.org/drawingml/2006/chart">
-            <c:chart xmlns:r="http://schemas.openxmlformats.org/officeDocument/2006/relationships" xmlns:c="http://schemas.openxmlformats.org/drawingml/2006/chart" r:id="R9e93513a50564504"/>
+            <c:chart xmlns:r="http://schemas.openxmlformats.org/officeDocument/2006/relationships" xmlns:c="http://schemas.openxmlformats.org/drawingml/2006/chart" r:id="Ra97e6cd2607c4805"/>
           </a:graphicData>
         </a:graphic>
       </p:graphicFrame>
       <p:graphicFrame>
         <p:nvGraphicFramePr>
-          <p:cNvPr id="13" name="Chart"/>
+          <p:cNvPr id="15" name="Chart"/>
           <p:cNvGraphicFramePr/>
           <p:nvPr/>
         </p:nvGraphicFramePr>
@@ -5606,7 +5688,7 @@
         </p:xfrm>
         <a:graphic xmlns:a="http://schemas.openxmlformats.org/drawingml/2006/main">
           <a:graphicData uri="http://schemas.openxmlformats.org/drawingml/2006/chart">
-            <c:chart xmlns:r="http://schemas.openxmlformats.org/officeDocument/2006/relationships" xmlns:c="http://schemas.openxmlformats.org/drawingml/2006/chart" r:id="R3aa2182f5daa4f0d"/>
+            <c:chart xmlns:r="http://schemas.openxmlformats.org/officeDocument/2006/relationships" xmlns:c="http://schemas.openxmlformats.org/drawingml/2006/chart" r:id="Rda0fd64027324027"/>
           </a:graphicData>
         </a:graphic>
       </p:graphicFrame>
@@ -5663,7 +5745,7 @@
                 <a:ea typeface="Arial"/>
                 <a:cs typeface="Arial"/>
               </a:rPr>
-              <a:t>O agente com memória pontuou mais nos três cenários e nas duas medidas.</a:t>
+              <a:t>Média aleatória em Pontos 2: 1031,60 (simples) e 1146,80 (memória).</a:t>
             </a:r>
           </a:p>
         </p:txBody>
@@ -5896,7 +5978,7 @@
                 <a:ea typeface="Arial"/>
                 <a:cs typeface="Arial"/>
               </a:rPr>
-              <a:t>A memória favoreceu a exploração</a:t>
+              <a:t>O mapa interno orienta a exploração</a:t>
             </a:r>
           </a:p>
           <a:p xmlns:a="http://schemas.openxmlformats.org/drawingml/2006/main">
@@ -5920,7 +6002,7 @@
                 <a:ea typeface="Arial"/>
                 <a:cs typeface="Arial"/>
               </a:rPr>
-              <a:t>e antecipou a limpeza nos testes.</a:t>
+              <a:t>e permite parar após concluir a limpeza.</a:t>
             </a:r>
           </a:p>
         </p:txBody>
@@ -5978,7 +6060,7 @@
                 <a:ea typeface="Arial"/>
                 <a:cs typeface="Arial"/>
               </a:rPr>
-              <a:t>Limitação dos agentes</a:t>
+              <a:t>Parada após explorar a região alcançável</a:t>
             </a:r>
           </a:p>
         </p:txBody>
@@ -6036,7 +6118,7 @@
                 <a:ea typeface="Arial"/>
                 <a:cs typeface="Arial"/>
               </a:rPr>
-              <a:t>Ambos continuam andando até completar 80 períodos.</a:t>
+              <a:t>Com memória: parada nos passos 20, 18 e 24.</a:t>
             </a:r>
           </a:p>
           <a:p xmlns:a="http://schemas.openxmlformats.org/drawingml/2006/main">
@@ -6060,7 +6142,7 @@
                 <a:ea typeface="Arial"/>
                 <a:cs typeface="Arial"/>
               </a:rPr>
-              <a:t>Após limpar tudo, esses movimentos reduzem os Pontos 2.</a:t>
+              <a:t>O simples continua andando até completar 80 períodos.</a:t>
             </a:r>
           </a:p>
         </p:txBody>
@@ -6176,7 +6258,7 @@
                 <a:ea typeface="Arial"/>
                 <a:cs typeface="Arial"/>
               </a:rPr>
-              <a:t>Melhor desempenho com memória nos testes realizados.</a:t>
+              <a:t>Maior pontuação P2 nos 30 mapas, frente à média do agente simples.</a:t>
             </a:r>
           </a:p>
           <a:p xmlns:a="http://schemas.openxmlformats.org/drawingml/2006/main">
@@ -6200,7 +6282,7 @@
                 <a:ea typeface="Arial"/>
                 <a:cs typeface="Arial"/>
               </a:rPr>
-              <a:t>Três cenários e uma semente não garantem superioridade geral.</a:t>
+              <a:t>Grade fixa, até dois obstáculos e cinco sementes limitam a conclusão.</a:t>
             </a:r>
           </a:p>
         </p:txBody>

</xml_diff>